<commit_message>
Sjöskolan v41 Del 3: fysiska stationer med motorn, startaren och strömtången
Ny teori, exempel, figurer och övningar 3.1–3.10 (EL-000877–886), omskrivna
kontrollfrågor, elevsidan Labbet.html, inlämning 3 och veckosidan.

Co-Authored-By: Claude Opus 5.5 <noreply@anthropic.com>
Claude-Session: https://claude.ai/code/session_011V9KjBb53XrDm23Dw58SH3
</commit_message>
<xml_diff>
--- a/sjoskolan/vecka-41/aktuell/v41_03_Fysisk_traff_och_matning_elev.pptx
+++ b/sjoskolan/vecka-41/aktuell/v41_03_Fysisk_traff_och_matning_elev.pptx
@@ -3628,7 +3628,7 @@
                 <a:ea typeface="Calibri"/>
                 <a:cs typeface="Calibri"/>
               </a:rPr>
-              <a:t>Stationsförslag med SELV-riggar och dokumentation</a:t>
+              <a:t>Motorn: delar, Y och Δ i plinten och strömtången</a:t>
             </a:r>
           </a:p>
         </p:txBody>
@@ -3846,7 +3846,29 @@
                 <a:ea typeface="Calibri"/>
                 <a:cs typeface="Calibri"/>
               </a:rPr>
-              <a:t>SELV kräver skyddande separation</a:t>
+              <a:t>Nätets U</a:t>
+            </a:r>
+            <a:r>
+              <a:rPr sz="2400" b="1" baseline="-25000">
+                <a:solidFill>
+                  <a:srgbClr val="064F91"/>
+                </a:solidFill>
+                <a:latin typeface="Calibri"/>
+                <a:ea typeface="Calibri"/>
+                <a:cs typeface="Calibri"/>
+              </a:rPr>
+              <a:t>L</a:t>
+            </a:r>
+            <a:r>
+              <a:rPr sz="2400" b="1">
+                <a:solidFill>
+                  <a:srgbClr val="064F91"/>
+                </a:solidFill>
+                <a:latin typeface="Calibri"/>
+                <a:ea typeface="Calibri"/>
+                <a:cs typeface="Calibri"/>
+              </a:rPr>
+              <a:t> = märkvärdet för driftkopplingen</a:t>
             </a:r>
           </a:p>
         </p:txBody>
@@ -3903,7 +3925,7 @@
                 <a:ea typeface="Calibri"/>
                 <a:cs typeface="Calibri"/>
               </a:rPr>
-              <a:t>SELV handlar om hur systemet är skyddat, bland annat om det är skilt från kretsar med högre spänning.</a:t>
+              <a:t>Märkningen Δ/Y anger två linjespänningar: den lägre hör till Δ och den högre till Y.</a:t>
             </a:r>
           </a:p>
         </p:txBody>
@@ -3960,7 +3982,7 @@
                 <a:ea typeface="Calibri"/>
                 <a:cs typeface="Calibri"/>
               </a:rPr>
-              <a:t>Förutsättningar: Riggen är märkt 12 V, men det finns ingen dokumentation om skyddet. Inget praktiskt moment får bygga på en gissning.</a:t>
+              <a:t>Förutsättningar: Ombord, 60 Hz. Märkskylt Δ/Y 254/440 V. Nätets linjespänning 440 V. Plintens övre rad är W2, U2, V2 och den undre U1, V1, W1.</a:t>
             </a:r>
           </a:p>
         </p:txBody>
@@ -4017,7 +4039,7 @@
                 <a:ea typeface="Calibri"/>
                 <a:cs typeface="Calibri"/>
               </a:rPr>
-              <a:t>Arbetsgång: Håll isär märkspänning och kontrollerat skydd. Ange vilken dokumentation instruktören måste kontrollera.</a:t>
+              <a:t>Arbetsgång: Jämför nätets linjespänning med de två märkvärdena. Beskriv sedan var blecken ska ligga för den kopplingen.</a:t>
             </a:r>
           </a:p>
         </p:txBody>
@@ -4236,7 +4258,7 @@
                 <a:ea typeface="Calibri"/>
                 <a:cs typeface="Calibri"/>
               </a:rPr>
-              <a:t>Kontroll före stationen</a:t>
+              <a:t>Blecken för fartygets nät</a:t>
             </a:r>
           </a:p>
         </p:txBody>
@@ -4258,7 +4280,7 @@
         <p:spPr>
           <a:xfrm xmlns:a="http://schemas.openxmlformats.org/drawingml/2006/main">
             <a:off x="762000" y="2533650"/>
-            <a:ext cx="7620000" cy="2286000"/>
+            <a:ext cx="3886200" cy="2606040"/>
           </a:xfrm>
           <a:prstGeom xmlns:a="http://schemas.openxmlformats.org/drawingml/2006/main" prst="rect">
             <a:avLst/>
@@ -4294,7 +4316,7 @@
                 <a:ea typeface="Calibri"/>
                 <a:cs typeface="Calibri"/>
               </a:rPr>
-              <a:t>En rigg är märkt 12 V men saknar dokumentation om skyddande separation. Kan spänningsvärdet ensamt användas som bevis för SELV?</a:t>
+              <a:t>En motor ombord har märkskylten Δ/Y 254/440 V, 60 Hz. Fartygets nät ger 440 V mellan faserna. Vilken koppling ska motorn ha, och hur lägger du blecken i plinten?</a:t>
             </a:r>
           </a:p>
         </p:txBody>
@@ -4415,6 +4437,30 @@
           </a:p>
         </p:txBody>
       </p:sp>
+      <p:pic xmlns:a="http://schemas.openxmlformats.org/drawingml/2006/main" xmlns:r="http://schemas.openxmlformats.org/officeDocument/2006/relationships">
+        <p:nvPicPr>
+          <p:cNvPr id="9" name="Figur: Märkskylt Δ/Y 254/440 V, 60 Hz och farty" descr="Märkskylt Δ/Y 254/440 V, 60 Hz och fartygets nät 440 V, 60 Hz; Y- och Δ-bleck att välja mellan"/>
+          <p:cNvPicPr>
+            <a:picLocks noChangeAspect="1"/>
+          </p:cNvPicPr>
+          <p:nvPr/>
+        </p:nvPicPr>
+        <p:blipFill>
+          <a:blip r:embed="rId3"/>
+          <a:stretch>
+            <a:fillRect/>
+          </a:stretch>
+        </p:blipFill>
+        <p:spPr>
+          <a:xfrm>
+            <a:off x="4846320" y="2331720"/>
+            <a:ext cx="3931920" cy="2740984"/>
+          </a:xfrm>
+          <a:prstGeom prst="rect">
+            <a:avLst/>
+          </a:prstGeom>
+        </p:spPr>
+      </p:pic>
     </p:spTree>
     <p:extLst>
       <p:ext uri="{BB962C8B-B14F-4D97-AF65-F5344CB8AC3E}">
@@ -4581,7 +4627,7 @@
                 <a:ea typeface="Calibri"/>
                 <a:cs typeface="Calibri"/>
               </a:rPr>
-              <a:t>total</a:t>
+              <a:t>lindning</a:t>
             </a:r>
             <a:r>
               <a:rPr sz="2400" b="1">
@@ -4603,7 +4649,7 @@
                 <a:ea typeface="Calibri"/>
                 <a:cs typeface="Calibri"/>
               </a:rPr>
-              <a:t>1</a:t>
+              <a:t>avläst</a:t>
             </a:r>
             <a:r>
               <a:rPr sz="2400" b="1">
@@ -4614,7 +4660,7 @@
                 <a:ea typeface="Calibri"/>
                 <a:cs typeface="Calibri"/>
               </a:rPr>
-              <a:t> + R</a:t>
+              <a:t> − R</a:t>
             </a:r>
             <a:r>
               <a:rPr sz="2400" b="1" baseline="-25000">
@@ -4625,85 +4671,7 @@
                 <a:ea typeface="Calibri"/>
                 <a:cs typeface="Calibri"/>
               </a:rPr>
-              <a:t>2</a:t>
-            </a:r>
-            <a:r>
-              <a:rPr sz="2400" b="1">
-                <a:solidFill>
-                  <a:srgbClr val="064F91"/>
-                </a:solidFill>
-                <a:latin typeface="Calibri"/>
-                <a:ea typeface="Calibri"/>
-                <a:cs typeface="Calibri"/>
-              </a:rPr>
-              <a:t>; I = U/R</a:t>
-            </a:r>
-            <a:r>
-              <a:rPr sz="2400" b="1" baseline="-25000">
-                <a:solidFill>
-                  <a:srgbClr val="064F91"/>
-                </a:solidFill>
-                <a:latin typeface="Calibri"/>
-                <a:ea typeface="Calibri"/>
-                <a:cs typeface="Calibri"/>
-              </a:rPr>
-              <a:t>total</a:t>
-            </a:r>
-          </a:p>
-          <a:p xmlns:a="http://schemas.openxmlformats.org/drawingml/2006/main">
-            <a:pPr algn="l">
-              <a:defRPr sz="2400" b="1">
-                <a:solidFill>
-                  <a:srgbClr val="064F91"/>
-                </a:solidFill>
-                <a:latin typeface="Calibri"/>
-                <a:ea typeface="Calibri"/>
-                <a:cs typeface="Calibri"/>
-              </a:defRPr>
-            </a:pPr>
-            <a:r>
-              <a:rPr sz="2400" b="1">
-                <a:solidFill>
-                  <a:srgbClr val="064F91"/>
-                </a:solidFill>
-                <a:latin typeface="Calibri"/>
-                <a:ea typeface="Calibri"/>
-                <a:cs typeface="Calibri"/>
-              </a:rPr>
-              <a:t>U</a:t>
-            </a:r>
-            <a:r>
-              <a:rPr sz="2400" b="1" baseline="-25000">
-                <a:solidFill>
-                  <a:srgbClr val="064F91"/>
-                </a:solidFill>
-                <a:latin typeface="Calibri"/>
-                <a:ea typeface="Calibri"/>
-                <a:cs typeface="Calibri"/>
-              </a:rPr>
-              <a:t>2</a:t>
-            </a:r>
-            <a:r>
-              <a:rPr sz="2400" b="1">
-                <a:solidFill>
-                  <a:srgbClr val="064F91"/>
-                </a:solidFill>
-                <a:latin typeface="Calibri"/>
-                <a:ea typeface="Calibri"/>
-                <a:cs typeface="Calibri"/>
-              </a:rPr>
-              <a:t> = I · R</a:t>
-            </a:r>
-            <a:r>
-              <a:rPr sz="2400" b="1" baseline="-25000">
-                <a:solidFill>
-                  <a:srgbClr val="064F91"/>
-                </a:solidFill>
-                <a:latin typeface="Calibri"/>
-                <a:ea typeface="Calibri"/>
-                <a:cs typeface="Calibri"/>
-              </a:rPr>
-              <a:t>2</a:t>
+              <a:t>sladdar</a:t>
             </a:r>
           </a:p>
         </p:txBody>
@@ -4760,7 +4728,7 @@
                 <a:ea typeface="Calibri"/>
                 <a:cs typeface="Calibri"/>
               </a:rPr>
-              <a:t>1 mA = 0,001 A. En voltmeter mäter mellan två punkter.</a:t>
+              <a:t>Mätsladdarna ligger i serie med lindningen. Multimetern visar summan.</a:t>
             </a:r>
           </a:p>
         </p:txBody>
@@ -4817,51 +4785,7 @@
                 <a:ea typeface="Calibri"/>
                 <a:cs typeface="Calibri"/>
               </a:rPr>
-              <a:t>Förutsättningar: Kontrollerad 12 V DC-rigg med R</a:t>
-            </a:r>
-            <a:r>
-              <a:rPr sz="2025" b="0" baseline="-25000">
-                <a:solidFill>
-                  <a:srgbClr val="111111"/>
-                </a:solidFill>
-                <a:latin typeface="Calibri"/>
-                <a:ea typeface="Calibri"/>
-                <a:cs typeface="Calibri"/>
-              </a:rPr>
-              <a:t>1</a:t>
-            </a:r>
-            <a:r>
-              <a:rPr sz="2025" b="0">
-                <a:solidFill>
-                  <a:srgbClr val="111111"/>
-                </a:solidFill>
-                <a:latin typeface="Calibri"/>
-                <a:ea typeface="Calibri"/>
-                <a:cs typeface="Calibri"/>
-              </a:rPr>
-              <a:t> = 1 kΩ och R</a:t>
-            </a:r>
-            <a:r>
-              <a:rPr sz="2025" b="0" baseline="-25000">
-                <a:solidFill>
-                  <a:srgbClr val="111111"/>
-                </a:solidFill>
-                <a:latin typeface="Calibri"/>
-                <a:ea typeface="Calibri"/>
-                <a:cs typeface="Calibri"/>
-              </a:rPr>
-              <a:t>2</a:t>
-            </a:r>
-            <a:r>
-              <a:rPr sz="2025" b="0">
-                <a:solidFill>
-                  <a:srgbClr val="111111"/>
-                </a:solidFill>
-                <a:latin typeface="Calibri"/>
-                <a:ea typeface="Calibri"/>
-                <a:cs typeface="Calibri"/>
-              </a:rPr>
-              <a:t> = 2 kΩ i serie. Räkna med exakta värden.</a:t>
+              <a:t>Förutsättningar: Spänningslös motor som aldrig är ansluten. Blecken borttagna. Sladdarnas resistans 0,3 Ω.</a:t>
             </a:r>
           </a:p>
         </p:txBody>
@@ -4918,51 +4842,7 @@
                 <a:ea typeface="Calibri"/>
                 <a:cs typeface="Calibri"/>
               </a:rPr>
-              <a:t>Arbetsgång: Räkna ut totalresistansen, strömmen och U</a:t>
-            </a:r>
-            <a:r>
-              <a:rPr sz="2025" b="0" baseline="-25000">
-                <a:solidFill>
-                  <a:srgbClr val="111111"/>
-                </a:solidFill>
-                <a:latin typeface="Calibri"/>
-                <a:ea typeface="Calibri"/>
-                <a:cs typeface="Calibri"/>
-              </a:rPr>
-              <a:t>2</a:t>
-            </a:r>
-            <a:r>
-              <a:rPr sz="2025" b="0">
-                <a:solidFill>
-                  <a:srgbClr val="111111"/>
-                </a:solidFill>
-                <a:latin typeface="Calibri"/>
-                <a:ea typeface="Calibri"/>
-                <a:cs typeface="Calibri"/>
-              </a:rPr>
-              <a:t>, och rita voltmetern parallellt över R</a:t>
-            </a:r>
-            <a:r>
-              <a:rPr sz="2025" b="0" baseline="-25000">
-                <a:solidFill>
-                  <a:srgbClr val="111111"/>
-                </a:solidFill>
-                <a:latin typeface="Calibri"/>
-                <a:ea typeface="Calibri"/>
-                <a:cs typeface="Calibri"/>
-              </a:rPr>
-              <a:t>2</a:t>
-            </a:r>
-            <a:r>
-              <a:rPr sz="2025" b="0">
-                <a:solidFill>
-                  <a:srgbClr val="111111"/>
-                </a:solidFill>
-                <a:latin typeface="Calibri"/>
-                <a:ea typeface="Calibri"/>
-                <a:cs typeface="Calibri"/>
-              </a:rPr>
-              <a:t>.</a:t>
+              <a:t>Arbetsgång: Dra av sladdarnas resistans från varje avläsning. Lägg sedan ihop de tre lindningarna och dela med tre.</a:t>
             </a:r>
           </a:p>
         </p:txBody>
@@ -5181,7 +5061,7 @@
                 <a:ea typeface="Calibri"/>
                 <a:cs typeface="Calibri"/>
               </a:rPr>
-              <a:t>Plan för DC-mätning</a:t>
+              <a:t>Lindningarna utan bleck</a:t>
             </a:r>
           </a:p>
         </p:txBody>
@@ -5239,29 +5119,7 @@
                 <a:ea typeface="Calibri"/>
                 <a:cs typeface="Calibri"/>
               </a:rPr>
-              <a:t>En kontrollerad 12 V-rigg har 1 kΩ och 2 kΩ i serie. Beräkna strömmen och rita hur en voltmeter ska anslutas för att mäta U</a:t>
-            </a:r>
-            <a:r>
-              <a:rPr sz="2400" b="0" baseline="-25000">
-                <a:solidFill>
-                  <a:srgbClr val="111111"/>
-                </a:solidFill>
-                <a:latin typeface="Calibri"/>
-                <a:ea typeface="Calibri"/>
-                <a:cs typeface="Calibri"/>
-              </a:rPr>
-              <a:t>2</a:t>
-            </a:r>
-            <a:r>
-              <a:rPr sz="2400" b="0">
-                <a:solidFill>
-                  <a:srgbClr val="111111"/>
-                </a:solidFill>
-                <a:latin typeface="Calibri"/>
-                <a:ea typeface="Calibri"/>
-                <a:cs typeface="Calibri"/>
-              </a:rPr>
-              <a:t>.</a:t>
+              <a:t>Sladdarna visar 0,3 Ω mot varandra. Utan bleck: U1–U2 4,1 Ω, V1–V2 4,0 Ω och W1–W2 4,2 Ω. Beräkna varje lindnings resistans och medelvärdet.</a:t>
             </a:r>
           </a:p>
         </p:txBody>
@@ -5384,7 +5242,7 @@
       </p:sp>
       <p:pic xmlns:a="http://schemas.openxmlformats.org/drawingml/2006/main" xmlns:r="http://schemas.openxmlformats.org/officeDocument/2006/relationships">
         <p:nvPicPr>
-          <p:cNvPr id="9" name="Figur: Seriekrets 12 V med 1 och 2 kiloohm; str" descr="Seriekrets 12 V med 1 och 2 kiloohm; ström och U2 okända"/>
+          <p:cNvPr id="9" name="Figur: Plint utan bleck med avläsningarna 4,1, 4,0 och 4,2 o" descr="Plint utan bleck med avläsningarna 4,1, 4,0 och 4,2 ohm och sladdarnas 0,3 ohm; lindningsresistansen okänd"/>
           <p:cNvPicPr>
             <a:picLocks noChangeAspect="1"/>
           </p:cNvPicPr>
@@ -5561,7 +5419,7 @@
                 <a:ea typeface="Calibri"/>
                 <a:cs typeface="Calibri"/>
               </a:rPr>
-              <a:t>U</a:t>
+              <a:t>Y: R</a:t>
             </a:r>
             <a:r>
               <a:rPr sz="2400" b="1" baseline="-25000">
@@ -5572,7 +5430,7 @@
                 <a:ea typeface="Calibri"/>
                 <a:cs typeface="Calibri"/>
               </a:rPr>
-              <a:t>källa</a:t>
+              <a:t>Y</a:t>
             </a:r>
             <a:r>
               <a:rPr sz="2400" b="1">
@@ -5583,7 +5441,7 @@
                 <a:ea typeface="Calibri"/>
                 <a:cs typeface="Calibri"/>
               </a:rPr>
-              <a:t> − U</a:t>
+              <a:t> = 2 · R</a:t>
             </a:r>
             <a:r>
               <a:rPr sz="2400" b="1" baseline="-25000">
@@ -5594,8 +5452,20 @@
                 <a:ea typeface="Calibri"/>
                 <a:cs typeface="Calibri"/>
               </a:rPr>
-              <a:t>1</a:t>
-            </a:r>
+              <a:t>lindning</a:t>
+            </a:r>
+          </a:p>
+          <a:p xmlns:a="http://schemas.openxmlformats.org/drawingml/2006/main">
+            <a:pPr algn="l">
+              <a:defRPr sz="2400" b="1">
+                <a:solidFill>
+                  <a:srgbClr val="064F91"/>
+                </a:solidFill>
+                <a:latin typeface="Calibri"/>
+                <a:ea typeface="Calibri"/>
+                <a:cs typeface="Calibri"/>
+              </a:defRPr>
+            </a:pPr>
             <a:r>
               <a:rPr sz="2400" b="1">
                 <a:solidFill>
@@ -5605,7 +5475,7 @@
                 <a:ea typeface="Calibri"/>
                 <a:cs typeface="Calibri"/>
               </a:rPr>
-              <a:t> − U</a:t>
+              <a:t>Δ: R</a:t>
             </a:r>
             <a:r>
               <a:rPr sz="2400" b="1" baseline="-25000">
@@ -5616,7 +5486,7 @@
                 <a:ea typeface="Calibri"/>
                 <a:cs typeface="Calibri"/>
               </a:rPr>
-              <a:t>2</a:t>
+              <a:t>Δ</a:t>
             </a:r>
             <a:r>
               <a:rPr sz="2400" b="1">
@@ -5627,7 +5497,18 @@
                 <a:ea typeface="Calibri"/>
                 <a:cs typeface="Calibri"/>
               </a:rPr>
-              <a:t> = 0</a:t>
+              <a:t> = (2/3) · R</a:t>
+            </a:r>
+            <a:r>
+              <a:rPr sz="2400" b="1" baseline="-25000">
+                <a:solidFill>
+                  <a:srgbClr val="064F91"/>
+                </a:solidFill>
+                <a:latin typeface="Calibri"/>
+                <a:ea typeface="Calibri"/>
+                <a:cs typeface="Calibri"/>
+              </a:rPr>
+              <a:t>lindning</a:t>
             </a:r>
           </a:p>
         </p:txBody>
@@ -5684,7 +5565,7 @@
                 <a:ea typeface="Calibri"/>
                 <a:cs typeface="Calibri"/>
               </a:rPr>
-              <a:t>Slinglagen jämför källspänning med summan av spänningsfallen. Alla värden anges i V.</a:t>
+              <a:t>I Y går vägen mellan två plintar genom två lindningar. I Δ ligger en lindning parallellt med två lindningar i serie.</a:t>
             </a:r>
           </a:p>
         </p:txBody>
@@ -5741,7 +5622,7 @@
                 <a:ea typeface="Calibri"/>
                 <a:cs typeface="Calibri"/>
               </a:rPr>
-              <a:t>Förutsättningar: Mätvärdena 11,94 V, 3,98 V och 7,96 V togs samtidigt i samma seriekrets.</a:t>
+              <a:t>Förutsättningar: Tre lika lindningar på 3,6 Ω. Mätsladdarnas resistans är redan avdragen.</a:t>
             </a:r>
           </a:p>
         </p:txBody>
@@ -5798,7 +5679,7 @@
                 <a:ea typeface="Calibri"/>
                 <a:cs typeface="Calibri"/>
               </a:rPr>
-              <a:t>Arbetsgång: Summera fallen och jämför med källan. Ange hur stor rest som återstår.</a:t>
+              <a:t>Arbetsgång: Räkna serie för Y. För Δ: räkna först de två lindningarna i serie och sedan parallellt med den tredje.</a:t>
             </a:r>
           </a:p>
         </p:txBody>
@@ -6017,7 +5898,7 @@
                 <a:ea typeface="Calibri"/>
                 <a:cs typeface="Calibri"/>
               </a:rPr>
-              <a:t>Observerade DC-värden</a:t>
+              <a:t>Förutsäg Y och Δ</a:t>
             </a:r>
           </a:p>
         </p:txBody>
@@ -6075,73 +5956,7 @@
                 <a:ea typeface="Calibri"/>
                 <a:cs typeface="Calibri"/>
               </a:rPr>
-              <a:t>U</a:t>
-            </a:r>
-            <a:r>
-              <a:rPr sz="2400" b="0" baseline="-25000">
-                <a:solidFill>
-                  <a:srgbClr val="111111"/>
-                </a:solidFill>
-                <a:latin typeface="Calibri"/>
-                <a:ea typeface="Calibri"/>
-                <a:cs typeface="Calibri"/>
-              </a:rPr>
-              <a:t>källa</a:t>
-            </a:r>
-            <a:r>
-              <a:rPr sz="2400" b="0">
-                <a:solidFill>
-                  <a:srgbClr val="111111"/>
-                </a:solidFill>
-                <a:latin typeface="Calibri"/>
-                <a:ea typeface="Calibri"/>
-                <a:cs typeface="Calibri"/>
-              </a:rPr>
-              <a:t> = 11,94 V, U</a:t>
-            </a:r>
-            <a:r>
-              <a:rPr sz="2400" b="0" baseline="-25000">
-                <a:solidFill>
-                  <a:srgbClr val="111111"/>
-                </a:solidFill>
-                <a:latin typeface="Calibri"/>
-                <a:ea typeface="Calibri"/>
-                <a:cs typeface="Calibri"/>
-              </a:rPr>
-              <a:t>1</a:t>
-            </a:r>
-            <a:r>
-              <a:rPr sz="2400" b="0">
-                <a:solidFill>
-                  <a:srgbClr val="111111"/>
-                </a:solidFill>
-                <a:latin typeface="Calibri"/>
-                <a:ea typeface="Calibri"/>
-                <a:cs typeface="Calibri"/>
-              </a:rPr>
-              <a:t> = 3,98 V och U</a:t>
-            </a:r>
-            <a:r>
-              <a:rPr sz="2400" b="0" baseline="-25000">
-                <a:solidFill>
-                  <a:srgbClr val="111111"/>
-                </a:solidFill>
-                <a:latin typeface="Calibri"/>
-                <a:ea typeface="Calibri"/>
-                <a:cs typeface="Calibri"/>
-              </a:rPr>
-              <a:t>2</a:t>
-            </a:r>
-            <a:r>
-              <a:rPr sz="2400" b="0">
-                <a:solidFill>
-                  <a:srgbClr val="111111"/>
-                </a:solidFill>
-                <a:latin typeface="Calibri"/>
-                <a:ea typeface="Calibri"/>
-                <a:cs typeface="Calibri"/>
-              </a:rPr>
-              <a:t> = 7,96 V. Kontrollera spänningslagen med mätvärdena.</a:t>
+              <a:t>En lindning har resistansen 3,6 Ω. Förutsäg resistansen mellan U1 och V1 när blecken ligger för Y och när de ligger för Δ.</a:t>
             </a:r>
           </a:p>
         </p:txBody>
@@ -6264,14 +6079,14 @@
       </p:sp>
       <p:pic xmlns:a="http://schemas.openxmlformats.org/drawingml/2006/main" xmlns:r="http://schemas.openxmlformats.org/officeDocument/2006/relationships">
         <p:nvPicPr>
-          <p:cNvPr id="9" name="Figur: Seriekrets där källan mäts till 11,94 V " descr="Seriekrets där källan mäts till 11,94 V och spänningsfallen till 3,98 och 7,96 V"/>
+          <p:cNvPr id="9" name="Figur: Y och Δ av tre lindningar på 3,6 ohm; resistansen mel" descr="Y och Δ av tre lindningar på 3,6 ohm; resistansen mellan U1 och V1 okänd i båda"/>
           <p:cNvPicPr>
             <a:picLocks noChangeAspect="1"/>
           </p:cNvPicPr>
           <p:nvPr/>
         </p:nvPicPr>
         <p:blipFill>
-          <a:blip r:embed="rId3"/>
+          <a:blip r:embed="rId4"/>
           <a:stretch>
             <a:fillRect/>
           </a:stretch>
@@ -6279,7 +6094,7 @@
         <p:spPr>
           <a:xfrm>
             <a:off x="4846320" y="2331720"/>
-            <a:ext cx="3931920" cy="2740984"/>
+            <a:ext cx="3931920" cy="2561913"/>
           </a:xfrm>
           <a:prstGeom prst="rect">
             <a:avLst/>
@@ -6441,18 +6256,7 @@
                 <a:ea typeface="Calibri"/>
                 <a:cs typeface="Calibri"/>
               </a:rPr>
-              <a:t>û = √2 · U</a:t>
-            </a:r>
-            <a:r>
-              <a:rPr sz="2400" b="1" baseline="-25000">
-                <a:solidFill>
-                  <a:srgbClr val="064F91"/>
-                </a:solidFill>
-                <a:latin typeface="Calibri"/>
-                <a:ea typeface="Calibri"/>
-                <a:cs typeface="Calibri"/>
-              </a:rPr>
-              <a:t>RMS</a:t>
+              <a:t>Märkskylten avgör kopplingen</a:t>
             </a:r>
           </a:p>
         </p:txBody>
@@ -6509,29 +6313,7 @@
                 <a:ea typeface="Calibri"/>
                 <a:cs typeface="Calibri"/>
               </a:rPr>
-              <a:t>û är toppvärdet och U</a:t>
-            </a:r>
-            <a:r>
-              <a:rPr sz="2100" b="0" baseline="-25000">
-                <a:solidFill>
-                  <a:srgbClr val="111111"/>
-                </a:solidFill>
-                <a:latin typeface="Calibri"/>
-                <a:ea typeface="Calibri"/>
-                <a:cs typeface="Calibri"/>
-              </a:rPr>
-              <a:t>RMS</a:t>
-            </a:r>
-            <a:r>
-              <a:rPr sz="2100" b="0">
-                <a:solidFill>
-                  <a:srgbClr val="111111"/>
-                </a:solidFill>
-                <a:latin typeface="Calibri"/>
-                <a:ea typeface="Calibri"/>
-                <a:cs typeface="Calibri"/>
-              </a:rPr>
-              <a:t> effektivvärdet.</a:t>
+              <a:t>Lindningsändarna sitter i plinten. Märkskylten anger spänning, ström, frekvens och effekt.</a:t>
             </a:r>
           </a:p>
         </p:txBody>
@@ -6588,7 +6370,7 @@
                 <a:ea typeface="Calibri"/>
                 <a:cs typeface="Calibri"/>
               </a:rPr>
-              <a:t>Förutsättningar: Ren sinus utan likspänningsdel. Mätvärdet 12,1 V är effektivvärdet.</a:t>
+              <a:t>Förutsättningar: Motorn har stomme med kylflänsar, fläktkåpa, lagersköldar, kopplingslåda och märkskylt. Den är aldrig ansluten.</a:t>
             </a:r>
           </a:p>
         </p:txBody>
@@ -6645,7 +6427,7 @@
                 <a:ea typeface="Calibri"/>
                 <a:cs typeface="Calibri"/>
               </a:rPr>
-              <a:t>Arbetsgång: Multiplicera med √2 och skriv att sambandet bara gäller sinusform.</a:t>
+              <a:t>Arbetsgång: Leta upp var lindningsändarna finns och vilken rad på skylten som anger två spänningar med Δ och Y.</a:t>
             </a:r>
           </a:p>
         </p:txBody>
@@ -6864,7 +6646,7 @@
                 <a:ea typeface="Calibri"/>
                 <a:cs typeface="Calibri"/>
               </a:rPr>
-              <a:t>AC-riggens toppvärde</a:t>
+              <a:t>Motorns delar</a:t>
             </a:r>
           </a:p>
         </p:txBody>
@@ -6922,7 +6704,7 @@
                 <a:ea typeface="Calibri"/>
                 <a:cs typeface="Calibri"/>
               </a:rPr>
-              <a:t>En sinusformad övningskälla mäts till 12,1 V RMS. Beräkna förväntat toppvärde.</a:t>
+              <a:t>Vilken del av motorn öppnar du för att koppla Y eller Δ, och vilka uppgifter på märkskylten avgör kopplingen? Vad gör fläkten och lagersköldarna?</a:t>
             </a:r>
           </a:p>
         </p:txBody>
@@ -7045,7 +6827,7 @@
       </p:sp>
       <p:pic xmlns:a="http://schemas.openxmlformats.org/drawingml/2006/main" xmlns:r="http://schemas.openxmlformats.org/officeDocument/2006/relationships">
         <p:nvPicPr>
-          <p:cNvPr id="9" name="Figur: Sinus med effektivvärdet 12,1 V; toppvär" descr="Sinus med effektivvärdet 12,1 V; toppvärdet okänt"/>
+          <p:cNvPr id="9" name="Figur: Trefasmotor från sidan utan etiketter; vilken del som" descr="Trefasmotor från sidan utan etiketter; vilken del som öppnas och vilka uppgifter som avgör kopplingen efterfrågas"/>
           <p:cNvPicPr>
             <a:picLocks noChangeAspect="1"/>
           </p:cNvPicPr>
@@ -7060,7 +6842,7 @@
         <p:spPr>
           <a:xfrm>
             <a:off x="4846320" y="2331720"/>
-            <a:ext cx="3931920" cy="2740984"/>
+            <a:ext cx="3931920" cy="2561913"/>
           </a:xfrm>
           <a:prstGeom prst="rect">
             <a:avLst/>
@@ -7222,7 +7004,7 @@
                 <a:ea typeface="Calibri"/>
                 <a:cs typeface="Calibri"/>
               </a:rPr>
-              <a:t>U</a:t>
+              <a:t>Kvot = R</a:t>
             </a:r>
             <a:r>
               <a:rPr sz="2400" b="1" baseline="-25000">
@@ -7233,7 +7015,7 @@
                 <a:ea typeface="Calibri"/>
                 <a:cs typeface="Calibri"/>
               </a:rPr>
-              <a:t>förv</a:t>
+              <a:t>Y</a:t>
             </a:r>
             <a:r>
               <a:rPr sz="2400" b="1">
@@ -7244,7 +7026,7 @@
                 <a:ea typeface="Calibri"/>
                 <a:cs typeface="Calibri"/>
               </a:rPr>
-              <a:t> = U</a:t>
+              <a:t>/R</a:t>
             </a:r>
             <a:r>
               <a:rPr sz="2400" b="1" baseline="-25000">
@@ -7255,18 +7037,7 @@
                 <a:ea typeface="Calibri"/>
                 <a:cs typeface="Calibri"/>
               </a:rPr>
-              <a:t>L</a:t>
-            </a:r>
-            <a:r>
-              <a:rPr sz="2400" b="1">
-                <a:solidFill>
-                  <a:srgbClr val="064F91"/>
-                </a:solidFill>
-                <a:latin typeface="Calibri"/>
-                <a:ea typeface="Calibri"/>
-                <a:cs typeface="Calibri"/>
-              </a:rPr>
-              <a:t>/√3</a:t>
+              <a:t>Δ</a:t>
             </a:r>
           </a:p>
           <a:p xmlns:a="http://schemas.openxmlformats.org/drawingml/2006/main">
@@ -7289,40 +7060,7 @@
                 <a:ea typeface="Calibri"/>
                 <a:cs typeface="Calibri"/>
               </a:rPr>
-              <a:t>ΔU = U</a:t>
-            </a:r>
-            <a:r>
-              <a:rPr sz="2400" b="1" baseline="-25000">
-                <a:solidFill>
-                  <a:srgbClr val="064F91"/>
-                </a:solidFill>
-                <a:latin typeface="Calibri"/>
-                <a:ea typeface="Calibri"/>
-                <a:cs typeface="Calibri"/>
-              </a:rPr>
-              <a:t>uppmätt</a:t>
-            </a:r>
-            <a:r>
-              <a:rPr sz="2400" b="1">
-                <a:solidFill>
-                  <a:srgbClr val="064F91"/>
-                </a:solidFill>
-                <a:latin typeface="Calibri"/>
-                <a:ea typeface="Calibri"/>
-                <a:cs typeface="Calibri"/>
-              </a:rPr>
-              <a:t> − U</a:t>
-            </a:r>
-            <a:r>
-              <a:rPr sz="2400" b="1" baseline="-25000">
-                <a:solidFill>
-                  <a:srgbClr val="064F91"/>
-                </a:solidFill>
-                <a:latin typeface="Calibri"/>
-                <a:ea typeface="Calibri"/>
-                <a:cs typeface="Calibri"/>
-              </a:rPr>
-              <a:t>förv</a:t>
+              <a:t>Avvikelse i % = 100 · (kvot − 3)/3</a:t>
             </a:r>
           </a:p>
         </p:txBody>
@@ -7379,7 +7117,51 @@
                 <a:ea typeface="Calibri"/>
                 <a:cs typeface="Calibri"/>
               </a:rPr>
-              <a:t>ΔU är avvikelsen med tecken. Ett negativt värde betyder att den uppmätta spänningen är lägre än den beräknade.</a:t>
+              <a:t>Kvoten 3 gäller oavsett lindningens resistans, eftersom R</a:t>
+            </a:r>
+            <a:r>
+              <a:rPr sz="2100" b="0" baseline="-25000">
+                <a:solidFill>
+                  <a:srgbClr val="111111"/>
+                </a:solidFill>
+                <a:latin typeface="Calibri"/>
+                <a:ea typeface="Calibri"/>
+                <a:cs typeface="Calibri"/>
+              </a:rPr>
+              <a:t>Y</a:t>
+            </a:r>
+            <a:r>
+              <a:rPr sz="2100" b="0">
+                <a:solidFill>
+                  <a:srgbClr val="111111"/>
+                </a:solidFill>
+                <a:latin typeface="Calibri"/>
+                <a:ea typeface="Calibri"/>
+                <a:cs typeface="Calibri"/>
+              </a:rPr>
+              <a:t> = 2R och R</a:t>
+            </a:r>
+            <a:r>
+              <a:rPr sz="2100" b="0" baseline="-25000">
+                <a:solidFill>
+                  <a:srgbClr val="111111"/>
+                </a:solidFill>
+                <a:latin typeface="Calibri"/>
+                <a:ea typeface="Calibri"/>
+                <a:cs typeface="Calibri"/>
+              </a:rPr>
+              <a:t>Δ</a:t>
+            </a:r>
+            <a:r>
+              <a:rPr sz="2100" b="0">
+                <a:solidFill>
+                  <a:srgbClr val="111111"/>
+                </a:solidFill>
+                <a:latin typeface="Calibri"/>
+                <a:ea typeface="Calibri"/>
+                <a:cs typeface="Calibri"/>
+              </a:rPr>
+              <a:t> = (2/3)R.</a:t>
             </a:r>
           </a:p>
         </p:txBody>
@@ -7436,51 +7218,7 @@
                 <a:ea typeface="Calibri"/>
                 <a:cs typeface="Calibri"/>
               </a:rPr>
-              <a:t>Förutsättningar: Symmetrisk Y, U</a:t>
-            </a:r>
-            <a:r>
-              <a:rPr sz="2025" b="0" baseline="-25000">
-                <a:solidFill>
-                  <a:srgbClr val="111111"/>
-                </a:solidFill>
-                <a:latin typeface="Calibri"/>
-                <a:ea typeface="Calibri"/>
-                <a:cs typeface="Calibri"/>
-              </a:rPr>
-              <a:t>L</a:t>
-            </a:r>
-            <a:r>
-              <a:rPr sz="2025" b="0">
-                <a:solidFill>
-                  <a:srgbClr val="111111"/>
-                </a:solidFill>
-                <a:latin typeface="Calibri"/>
-                <a:ea typeface="Calibri"/>
-                <a:cs typeface="Calibri"/>
-              </a:rPr>
-              <a:t> = 12,0 V och U</a:t>
-            </a:r>
-            <a:r>
-              <a:rPr sz="2025" b="0" baseline="-25000">
-                <a:solidFill>
-                  <a:srgbClr val="111111"/>
-                </a:solidFill>
-                <a:latin typeface="Calibri"/>
-                <a:ea typeface="Calibri"/>
-                <a:cs typeface="Calibri"/>
-              </a:rPr>
-              <a:t>uppmätt</a:t>
-            </a:r>
-            <a:r>
-              <a:rPr sz="2025" b="0">
-                <a:solidFill>
-                  <a:srgbClr val="111111"/>
-                </a:solidFill>
-                <a:latin typeface="Calibri"/>
-                <a:ea typeface="Calibri"/>
-                <a:cs typeface="Calibri"/>
-              </a:rPr>
-              <a:t> = 6,90 V. Avrunda inte mellanresultatet.</a:t>
+              <a:t>Förutsättningar: Samma motor, samma par U1–V1. Förväntad kvot 3.</a:t>
             </a:r>
           </a:p>
         </p:txBody>
@@ -7537,7 +7275,7 @@
                 <a:ea typeface="Calibri"/>
                 <a:cs typeface="Calibri"/>
               </a:rPr>
-              <a:t>Arbetsgång: Räkna ut den förväntade grenspänningen, dra den från mätvärdet och tolka tecknet.</a:t>
+              <a:t>Arbetsgång: Dela Y-värdet med Δ-värdet, jämför med 3 och räkna avvikelsen i procent.</a:t>
             </a:r>
           </a:p>
         </p:txBody>
@@ -7756,7 +7494,7 @@
                 <a:ea typeface="Calibri"/>
                 <a:cs typeface="Calibri"/>
               </a:rPr>
-              <a:t>Trefasdata</a:t>
+              <a:t>Kvoten mellan Y och Δ</a:t>
             </a:r>
           </a:p>
         </p:txBody>
@@ -7814,7 +7552,51 @@
                 <a:ea typeface="Calibri"/>
                 <a:cs typeface="Calibri"/>
               </a:rPr>
-              <a:t>En symmetrisk trefasrigg har uppmätt linjespänning 12,0 V. Beräkna förväntad Y-grenspänning och jämför med uppmätt 6,90 V.</a:t>
+              <a:t>I labbet mättes U1–V1 till 8,1 Ω i Y och 2,8 Ω i Δ (sladdarna avdragna). Beräkna kvoten R</a:t>
+            </a:r>
+            <a:r>
+              <a:rPr sz="2400" b="0" baseline="-25000">
+                <a:solidFill>
+                  <a:srgbClr val="111111"/>
+                </a:solidFill>
+                <a:latin typeface="Calibri"/>
+                <a:ea typeface="Calibri"/>
+                <a:cs typeface="Calibri"/>
+              </a:rPr>
+              <a:t>Y</a:t>
+            </a:r>
+            <a:r>
+              <a:rPr sz="2400" b="0">
+                <a:solidFill>
+                  <a:srgbClr val="111111"/>
+                </a:solidFill>
+                <a:latin typeface="Calibri"/>
+                <a:ea typeface="Calibri"/>
+                <a:cs typeface="Calibri"/>
+              </a:rPr>
+              <a:t>/R</a:t>
+            </a:r>
+            <a:r>
+              <a:rPr sz="2400" b="0" baseline="-25000">
+                <a:solidFill>
+                  <a:srgbClr val="111111"/>
+                </a:solidFill>
+                <a:latin typeface="Calibri"/>
+                <a:ea typeface="Calibri"/>
+                <a:cs typeface="Calibri"/>
+              </a:rPr>
+              <a:t>Δ</a:t>
+            </a:r>
+            <a:r>
+              <a:rPr sz="2400" b="0">
+                <a:solidFill>
+                  <a:srgbClr val="111111"/>
+                </a:solidFill>
+                <a:latin typeface="Calibri"/>
+                <a:ea typeface="Calibri"/>
+                <a:cs typeface="Calibri"/>
+              </a:rPr>
+              <a:t> och avvikelsen från 3 i procent. Låg blecken rätt?</a:t>
             </a:r>
           </a:p>
         </p:txBody>
@@ -7937,7 +7719,7 @@
       </p:sp>
       <p:pic xmlns:a="http://schemas.openxmlformats.org/drawingml/2006/main" xmlns:r="http://schemas.openxmlformats.org/officeDocument/2006/relationships">
         <p:nvPicPr>
-          <p:cNvPr id="9" name="Figur: Y-last med linjespänningen 12,0 V och up" descr="Y-last med linjespänningen 12,0 V och uppmätt grenspänning 6,90 V; förväntat värde okänt"/>
+          <p:cNvPr id="9" name="Figur: Stapeldiagram: U1–V1 8,1 ohm i Y och 2,8 ohm i Δ; kvo" descr="Stapeldiagram: U1–V1 8,1 ohm i Y och 2,8 ohm i Δ; kvoten okänd"/>
           <p:cNvPicPr>
             <a:picLocks noChangeAspect="1"/>
           </p:cNvPicPr>
@@ -8116,7 +7898,7 @@
                 <a:ea typeface="Calibri"/>
                 <a:cs typeface="Calibri"/>
               </a:rPr>
-              <a:t>Jämföra beräknade värden med kontrollerade mätdata.</a:t>
+              <a:t>Koppla Y och Δ i en motors plint och kontrollera kopplingen med mätning.</a:t>
             </a:r>
           </a:p>
         </p:txBody>
@@ -8174,7 +7956,7 @@
                 <a:ea typeface="Calibri"/>
                 <a:cs typeface="Calibri"/>
               </a:rPr>
-              <a:t>Planera och dokumentera en mätning med handledare.</a:t>
+              <a:t>Känna igen motorns och startarens delar och förklara vad en strömtång mäter.</a:t>
             </a:r>
           </a:p>
         </p:txBody>
@@ -8290,7 +8072,7 @@
                 <a:ea typeface="Calibri"/>
                 <a:cs typeface="Calibri"/>
               </a:rPr>
-              <a:t>Vilken information visar att en 12 V-utrustning verkligen är en SELV-rigg?</a:t>
+              <a:t>Motorn har sex plintar. Hur tar du reda på vilka två som hör till samma lindning?</a:t>
             </a:r>
           </a:p>
         </p:txBody>
@@ -8510,7 +8292,7 @@
                 <a:ea typeface="Calibri"/>
                 <a:cs typeface="Calibri"/>
               </a:rPr>
-              <a:t>Station C: hållkrets</a:t>
+              <a:t>Startarens delar</a:t>
             </a:r>
           </a:p>
           <a:p xmlns:a="http://schemas.openxmlformats.org/drawingml/2006/main">
@@ -8534,7 +8316,7 @@
                 <a:ea typeface="Calibri"/>
                 <a:cs typeface="Calibri"/>
               </a:rPr>
-              <a:t>Mätprotokoll och rimlighet</a:t>
+              <a:t>Strömtången</a:t>
             </a:r>
           </a:p>
           <a:p xmlns:a="http://schemas.openxmlformats.org/drawingml/2006/main">
@@ -8558,7 +8340,7 @@
                 <a:ea typeface="Calibri"/>
                 <a:cs typeface="Calibri"/>
               </a:rPr>
-              <a:t>Individuell återkoppling</a:t>
+              <a:t>Protokoll och slutsats</a:t>
             </a:r>
           </a:p>
         </p:txBody>
@@ -8802,7 +8584,7 @@
                 <a:ea typeface="Calibri"/>
                 <a:cs typeface="Calibri"/>
               </a:rPr>
-              <a:t>Station C: hållkrets</a:t>
+              <a:t>Startarens delar</a:t>
             </a:r>
           </a:p>
         </p:txBody>
@@ -8860,7 +8642,7 @@
                 <a:ea typeface="Calibri"/>
                 <a:cs typeface="Calibri"/>
               </a:rPr>
-              <a:t>STOPP är normalt sluten. START är normalt öppen.</a:t>
+              <a:t>Kontaktorn K1 kopplar motorns tre faser med huvudkontakterna. Spolen A1–A2 drar den.</a:t>
             </a:r>
           </a:p>
           <a:p xmlns:a="http://schemas.openxmlformats.org/drawingml/2006/main">
@@ -8884,7 +8666,7 @@
                 <a:ea typeface="Calibri"/>
                 <a:cs typeface="Calibri"/>
               </a:rPr>
-              <a:t>K1:s hjälpkontakt håller spolens matning efter start.</a:t>
+              <a:t>13–14 är normalt öppen. 95–96 på överlastreläet är normalt sluten.</a:t>
             </a:r>
           </a:p>
         </p:txBody>
@@ -8942,7 +8724,7 @@
                 <a:ea typeface="Calibri"/>
                 <a:cs typeface="Calibri"/>
               </a:rPr>
-              <a:t>Vila, start, hållning och stopp</a:t>
+              <a:t>Överlastreläet ställs på motorns märkström</a:t>
             </a:r>
           </a:p>
         </p:txBody>
@@ -9000,7 +8782,7 @@
                 <a:ea typeface="Calibri"/>
                 <a:cs typeface="Calibri"/>
               </a:rPr>
-              <a:t>Instruktören använder säkra förberedda felmoduler.</a:t>
+              <a:t>Startaren ansluts aldrig i labbet. Kontakterna mäts spänningslöst.</a:t>
             </a:r>
           </a:p>
           <a:p xmlns:a="http://schemas.openxmlformats.org/drawingml/2006/main">
@@ -9024,7 +8806,7 @@
                 <a:ea typeface="Calibri"/>
                 <a:cs typeface="Calibri"/>
               </a:rPr>
-              <a:t>Eleven jämför förväntad funktion med observerad funktion.</a:t>
+              <a:t>Hållkretsen kommer tillbaka vecka 43.</a:t>
             </a:r>
           </a:p>
         </p:txBody>
@@ -9089,22 +8871,22 @@
       </p:sp>
       <p:pic xmlns:a="http://schemas.openxmlformats.org/drawingml/2006/main" xmlns:r="http://schemas.openxmlformats.org/officeDocument/2006/relationships">
         <p:nvPicPr>
-          <p:cNvPr id="38" name="schema-hallkrets" descr="+12 V – S0 STOPP (NC) – S1 START (NO) parallellt med K1 (NO) – spolen K1 – 0 V."/>
+          <p:cNvPr id="38" name="Figur: Startarens delar: kontaktor K1 med spole A1–A2, huvud" descr="Startarens delar: kontaktor K1 med spole A1–A2, huvudkontakter 1–2, 3–4, 5–6, hjälpkontakt 13–14 (NO) och överlastrelä F2 med 95–96 (NC)"/>
           <p:cNvPicPr>
             <a:picLocks noChangeAspect="1"/>
           </p:cNvPicPr>
           <p:nvPr/>
         </p:nvPicPr>
         <p:blipFill>
-          <a:blip r:embed="rId3"/>
+          <a:blip r:embed="rId4"/>
           <a:stretch>
             <a:fillRect/>
           </a:stretch>
         </p:blipFill>
         <p:spPr>
           <a:xfrm>
-            <a:off x="1138733" y="2395728"/>
-            <a:ext cx="6866534" cy="2340864"/>
+            <a:off x="2231136" y="2395728"/>
+            <a:ext cx="4681728" cy="2340864"/>
           </a:xfrm>
           <a:prstGeom prst="rect">
             <a:avLst/>
@@ -9210,7 +8992,7 @@
                 <a:ea typeface="Calibri"/>
                 <a:cs typeface="Calibri"/>
               </a:rPr>
-              <a:t>Mätprotokoll och rimlighet</a:t>
+              <a:t>Strömtången</a:t>
             </a:r>
           </a:p>
         </p:txBody>
@@ -9232,7 +9014,7 @@
         <p:spPr>
           <a:xfrm xmlns:a="http://schemas.openxmlformats.org/drawingml/2006/main">
             <a:off x="762000" y="1619250"/>
-            <a:ext cx="7620000" cy="1466850"/>
+            <a:ext cx="3977639" cy="1466850"/>
           </a:xfrm>
           <a:prstGeom xmlns:a="http://schemas.openxmlformats.org/drawingml/2006/main" prst="rect">
             <a:avLst/>
@@ -9260,15 +9042,15 @@
               </a:defRPr>
             </a:pPr>
             <a:r>
-              <a:rPr sz="2400" b="0">
-                <a:solidFill>
-                  <a:srgbClr val="111111"/>
-                </a:solidFill>
-                <a:latin typeface="Calibri"/>
-                <a:ea typeface="Calibri"/>
-                <a:cs typeface="Calibri"/>
-              </a:rPr>
-              <a:t>Varje deltagare skriver ett eget protokoll.</a:t>
+              <a:rPr sz="2050" b="0">
+                <a:solidFill>
+                  <a:srgbClr val="111111"/>
+                </a:solidFill>
+                <a:latin typeface="Calibri"/>
+                <a:ea typeface="Calibri"/>
+                <a:cs typeface="Calibri"/>
+              </a:rPr>
+              <a:t>Tången mäter summan av strömmarna som går genom käften.</a:t>
             </a:r>
           </a:p>
           <a:p xmlns:a="http://schemas.openxmlformats.org/drawingml/2006/main">
@@ -9284,15 +9066,15 @@
               </a:defRPr>
             </a:pPr>
             <a:r>
-              <a:rPr sz="2400" b="0">
-                <a:solidFill>
-                  <a:srgbClr val="111111"/>
-                </a:solidFill>
-                <a:latin typeface="Calibri"/>
-                <a:ea typeface="Calibri"/>
-                <a:cs typeface="Calibri"/>
-              </a:rPr>
-              <a:t>Anteckna både beräkning, verkligt värde och mätvillkor.</a:t>
+              <a:rPr sz="2050" b="0">
+                <a:solidFill>
+                  <a:srgbClr val="111111"/>
+                </a:solidFill>
+                <a:latin typeface="Calibri"/>
+                <a:ea typeface="Calibri"/>
+                <a:cs typeface="Calibri"/>
+              </a:rPr>
+              <a:t>Nollställ tången i läget DC A före mätningen.</a:t>
             </a:r>
           </a:p>
         </p:txBody>
@@ -9314,7 +9096,7 @@
         <p:spPr>
           <a:xfrm xmlns:a="http://schemas.openxmlformats.org/drawingml/2006/main">
             <a:off x="762000" y="3200400"/>
-            <a:ext cx="7620000" cy="838200"/>
+            <a:ext cx="3977639" cy="838200"/>
           </a:xfrm>
           <a:prstGeom xmlns:a="http://schemas.openxmlformats.org/drawingml/2006/main" prst="rect">
             <a:avLst/>
@@ -9342,7 +9124,7 @@
               </a:defRPr>
             </a:pPr>
             <a:r>
-              <a:rPr sz="2925" b="1">
+              <a:rPr sz="2650" b="1">
                 <a:solidFill>
                   <a:srgbClr val="064F91"/>
                 </a:solidFill>
@@ -9350,7 +9132,31 @@
                 <a:ea typeface="Calibri"/>
                 <a:cs typeface="Calibri"/>
               </a:rPr>
-              <a:t>Avvikelse = uppmätt − förväntat</a:t>
+              <a:t>Två varv: 2 · I</a:t>
+            </a:r>
+          </a:p>
+          <a:p xmlns:a="http://schemas.openxmlformats.org/drawingml/2006/main">
+            <a:pPr algn="l">
+              <a:buNone/>
+              <a:defRPr sz="2925" b="1">
+                <a:solidFill>
+                  <a:srgbClr val="064F91"/>
+                </a:solidFill>
+                <a:latin typeface="Calibri"/>
+                <a:ea typeface="Calibri"/>
+                <a:cs typeface="Calibri"/>
+              </a:defRPr>
+            </a:pPr>
+            <a:r>
+              <a:rPr sz="2650" b="1">
+                <a:solidFill>
+                  <a:srgbClr val="064F91"/>
+                </a:solidFill>
+                <a:latin typeface="Calibri"/>
+                <a:ea typeface="Calibri"/>
+                <a:cs typeface="Calibri"/>
+              </a:rPr>
+              <a:t>Ut och tillbaka: 0</a:t>
             </a:r>
           </a:p>
         </p:txBody>
@@ -9372,7 +9178,7 @@
         <p:spPr>
           <a:xfrm xmlns:a="http://schemas.openxmlformats.org/drawingml/2006/main">
             <a:off x="762000" y="4429125"/>
-            <a:ext cx="7620000" cy="1352550"/>
+            <a:ext cx="3977639" cy="1352550"/>
           </a:xfrm>
           <a:prstGeom xmlns:a="http://schemas.openxmlformats.org/drawingml/2006/main" prst="rect">
             <a:avLst/>
@@ -9400,15 +9206,15 @@
               </a:defRPr>
             </a:pPr>
             <a:r>
-              <a:rPr sz="2250" b="0">
-                <a:solidFill>
-                  <a:srgbClr val="111111"/>
-                </a:solidFill>
-                <a:latin typeface="Calibri"/>
-                <a:ea typeface="Calibri"/>
-                <a:cs typeface="Calibri"/>
-              </a:rPr>
-              <a:t>Toleranser, källspänning och instrumentdata påverkar jämförelsen.</a:t>
+              <a:rPr sz="1700" b="0">
+                <a:solidFill>
+                  <a:srgbClr val="111111"/>
+                </a:solidFill>
+                <a:latin typeface="Calibri"/>
+                <a:ea typeface="Calibri"/>
+                <a:cs typeface="Calibri"/>
+              </a:rPr>
+              <a:t>Mät en fasledare i taget. Runt en hel trefaskabel blir summan nära noll.</a:t>
             </a:r>
           </a:p>
           <a:p xmlns:a="http://schemas.openxmlformats.org/drawingml/2006/main">
@@ -9424,15 +9230,15 @@
               </a:defRPr>
             </a:pPr>
             <a:r>
-              <a:rPr sz="2250" b="0">
-                <a:solidFill>
-                  <a:srgbClr val="111111"/>
-                </a:solidFill>
-                <a:latin typeface="Calibri"/>
-                <a:ea typeface="Calibri"/>
-                <a:cs typeface="Calibri"/>
-              </a:rPr>
-              <a:t>En skillnad är inte automatiskt ett fel.</a:t>
+              <a:rPr sz="1700" b="0">
+                <a:solidFill>
+                  <a:srgbClr val="111111"/>
+                </a:solidFill>
+                <a:latin typeface="Calibri"/>
+                <a:ea typeface="Calibri"/>
+                <a:cs typeface="Calibri"/>
+              </a:rPr>
+              <a:t>Samma princip används i jordfelsbrytaren.</a:t>
             </a:r>
           </a:p>
         </p:txBody>
@@ -9495,6 +9301,30 @@
           </a:p>
         </p:txBody>
       </p:sp>
+      <p:pic xmlns:a="http://schemas.openxmlformats.org/drawingml/2006/main" xmlns:r="http://schemas.openxmlformats.org/officeDocument/2006/relationships">
+        <p:nvPicPr>
+          <p:cNvPr id="9" name="Figur: Strömtångens käft: en ledare ger I, två " descr="Strömtångens käft: en ledare ger I, två varv ger 2 · I, hårnål med ström in och ut ger 0"/>
+          <p:cNvPicPr>
+            <a:picLocks noChangeAspect="1"/>
+          </p:cNvPicPr>
+          <p:nvPr/>
+        </p:nvPicPr>
+        <p:blipFill>
+          <a:blip r:embed="rId3"/>
+          <a:stretch>
+            <a:fillRect/>
+          </a:stretch>
+        </p:blipFill>
+        <p:spPr>
+          <a:xfrm>
+            <a:off x="4892040" y="1645920"/>
+            <a:ext cx="3886200" cy="2027729"/>
+          </a:xfrm>
+          <a:prstGeom prst="rect">
+            <a:avLst/>
+          </a:prstGeom>
+        </p:spPr>
+      </p:pic>
     </p:spTree>
     <p:extLst>
       <p:ext uri="{BB962C8B-B14F-4D97-AF65-F5344CB8AC3E}">
@@ -9594,7 +9424,7 @@
                 <a:ea typeface="Calibri"/>
                 <a:cs typeface="Calibri"/>
               </a:rPr>
-              <a:t>Individuell återkoppling</a:t>
+              <a:t>Protokoll och slutsats</a:t>
             </a:r>
           </a:p>
         </p:txBody>
@@ -9652,7 +9482,7 @@
                 <a:ea typeface="Calibri"/>
                 <a:cs typeface="Calibri"/>
               </a:rPr>
-              <a:t>Varje deltagare motiverar minst ett metodval.</a:t>
+              <a:t>Varje deltagare skriver ett eget protokoll: mätpunkter, instrument och värden.</a:t>
             </a:r>
           </a:p>
           <a:p xmlns:a="http://schemas.openxmlformats.org/drawingml/2006/main">
@@ -9676,7 +9506,7 @@
                 <a:ea typeface="Calibri"/>
                 <a:cs typeface="Calibri"/>
               </a:rPr>
-              <a:t>Handledaren dokumenterar vad personen faktiskt genomförde.</a:t>
+              <a:t>Det förväntade värdet står i protokollet före mätningen.</a:t>
             </a:r>
           </a:p>
         </p:txBody>
@@ -9734,7 +9564,7 @@
                 <a:ea typeface="Calibri"/>
                 <a:cs typeface="Calibri"/>
               </a:rPr>
-              <a:t>Observation och slutsats hålls isär</a:t>
+              <a:t>Avvikelse = uppmätt − förväntat</a:t>
             </a:r>
           </a:p>
         </p:txBody>
@@ -9792,7 +9622,7 @@
                 <a:ea typeface="Calibri"/>
                 <a:cs typeface="Calibri"/>
               </a:rPr>
-              <a:t>Exempel: ”K1 släpper efter START” är en observation.</a:t>
+              <a:t>Observation: ”U1–V1 visar 2R i Y”. Slutsats: ”blecken ligger rätt”.</a:t>
             </a:r>
           </a:p>
           <a:p xmlns:a="http://schemas.openxmlformats.org/drawingml/2006/main">
@@ -9816,7 +9646,7 @@
                 <a:ea typeface="Calibri"/>
                 <a:cs typeface="Calibri"/>
               </a:rPr>
-              <a:t>”Avbrott i hållvägen” är en hypotes som behöver prövas.</a:t>
+              <a:t>Håll isär observation och slutsats.</a:t>
             </a:r>
           </a:p>
         </p:txBody>
@@ -9977,7 +9807,7 @@
                 <a:ea typeface="Calibri"/>
                 <a:cs typeface="Calibri"/>
               </a:rPr>
-              <a:t>Exempel: tolkning av ett mätvärde</a:t>
+              <a:t>Exempel: strömtången med flera varv</a:t>
             </a:r>
           </a:p>
         </p:txBody>
@@ -10034,7 +9864,7 @@
                 <a:ea typeface="Calibri"/>
                 <a:cs typeface="Calibri"/>
               </a:rPr>
-              <a:t>En 2 kΩ-resistor har toleransen ±5 %. Den mäts till 2,06 kΩ. Instrumentfel försummas här.</a:t>
+              <a:t>Ett aggregat driver 1,5 A genom en labbsladd. Sladden läggs tre varv genom tången och sedan som en hårnål.</a:t>
             </a:r>
           </a:p>
         </p:txBody>
@@ -10091,29 +9921,7 @@
                 <a:ea typeface="Calibri"/>
                 <a:cs typeface="Calibri"/>
               </a:rPr>
-              <a:t>Gränser = R</a:t>
-            </a:r>
-            <a:r>
-              <a:rPr sz="2325" b="1" baseline="-25000">
-                <a:solidFill>
-                  <a:srgbClr val="064F91"/>
-                </a:solidFill>
-                <a:latin typeface="Calibri"/>
-                <a:ea typeface="Calibri"/>
-                <a:cs typeface="Calibri"/>
-              </a:rPr>
-              <a:t>nom</a:t>
-            </a:r>
-            <a:r>
-              <a:rPr sz="2325" b="1">
-                <a:solidFill>
-                  <a:srgbClr val="064F91"/>
-                </a:solidFill>
-                <a:latin typeface="Calibri"/>
-                <a:ea typeface="Calibri"/>
-                <a:cs typeface="Calibri"/>
-              </a:rPr>
-              <a:t> · (1 ± p/100)</a:t>
+              <a:t>Visat värde = summan av strömmarna genom käften</a:t>
             </a:r>
           </a:p>
         </p:txBody>
@@ -10170,7 +9978,7 @@
                 <a:ea typeface="Calibri"/>
                 <a:cs typeface="Calibri"/>
               </a:rPr>
-              <a:t>1. Nedre gräns = 2 · 0,95 = 1,90 kΩ.</a:t>
+              <a:t>1. En gång genom käften: 1,5 A.</a:t>
             </a:r>
           </a:p>
           <a:p xmlns:a="http://schemas.openxmlformats.org/drawingml/2006/main">
@@ -10193,7 +10001,7 @@
                 <a:ea typeface="Calibri"/>
                 <a:cs typeface="Calibri"/>
               </a:rPr>
-              <a:t>2. Övre gräns = 2 · 1,05 = 2,10 kΩ.</a:t>
+              <a:t>2. Tre varv: 3 · 1,5 = 4,5 A.</a:t>
             </a:r>
           </a:p>
           <a:p xmlns:a="http://schemas.openxmlformats.org/drawingml/2006/main">
@@ -10216,7 +10024,7 @@
                 <a:ea typeface="Calibri"/>
                 <a:cs typeface="Calibri"/>
               </a:rPr>
-              <a:t>3. 2,06 kΩ ligger mellan gränserna och uppfyller övningskravet.</a:t>
+              <a:t>3. Hårnål: +1,5 − 1,5 = 0 A.</a:t>
             </a:r>
           </a:p>
         </p:txBody>
@@ -10273,7 +10081,7 @@
                 <a:ea typeface="Calibri"/>
                 <a:cs typeface="Calibri"/>
               </a:rPr>
-              <a:t>Verklig bedömning behöver även instrumentets bidrag och jämförbara mätvillkor.</a:t>
+              <a:t>Kontroll: tången räknar varje passage genom käften, med riktning.</a:t>
             </a:r>
           </a:p>
         </p:txBody>
@@ -10490,7 +10298,18 @@
                 <a:ea typeface="Calibri"/>
                 <a:cs typeface="Calibri"/>
               </a:rPr>
-              <a:t>Matad spole kräver sluten väg från + till 0 V</a:t>
+              <a:t>Δ: alla par (2/3) · R</a:t>
+            </a:r>
+            <a:r>
+              <a:rPr sz="2400" b="1" baseline="-25000">
+                <a:solidFill>
+                  <a:srgbClr val="064F91"/>
+                </a:solidFill>
+                <a:latin typeface="Calibri"/>
+                <a:ea typeface="Calibri"/>
+                <a:cs typeface="Calibri"/>
+              </a:rPr>
+              <a:t>lindning</a:t>
             </a:r>
           </a:p>
         </p:txBody>
@@ -10547,7 +10366,7 @@
                 <a:ea typeface="Calibri"/>
                 <a:cs typeface="Calibri"/>
               </a:rPr>
-              <a:t>NC är normalt sluten och NO normalt öppen. K1:s NO-hållkontakt är öppen när spolen inte är påverkad.</a:t>
+              <a:t>I en hel Δ-koppling visar alla tre paren samma värde. Två par med en lindning och ett par med två lindningar i serie betyder att triangeln är öppen.</a:t>
             </a:r>
           </a:p>
         </p:txBody>
@@ -10604,7 +10423,7 @@
                 <a:ea typeface="Calibri"/>
                 <a:cs typeface="Calibri"/>
               </a:rPr>
-              <a:t>Förutsättningar: Hållkretsen i figuren: S0 sluten, S1 öppen, K1 i vila. Returen är hel.</a:t>
+              <a:t>Förutsättningar: Spänningslös motor. Sladdarnas resistans avdragen. Δ-blecken ska vara U1–W2, V1–U2 och W1–V2.</a:t>
             </a:r>
           </a:p>
         </p:txBody>
@@ -10661,7 +10480,7 @@
                 <a:ea typeface="Calibri"/>
                 <a:cs typeface="Calibri"/>
               </a:rPr>
-              <a:t>Arbetsgång: Följ båda de parallella vägarna efter S0 och avgör om någon av dem är obruten ända fram till spolen.</a:t>
+              <a:t>Arbetsgång: Räkna först vad en hel Δ skulle ge. Rita sedan triangeln och ta bort ett bleck i taget tills mätvärdena stämmer.</a:t>
             </a:r>
           </a:p>
         </p:txBody>
@@ -10880,7 +10699,7 @@
                 <a:ea typeface="Calibri"/>
                 <a:cs typeface="Calibri"/>
               </a:rPr>
-              <a:t>Hållkretsens vila</a:t>
+              <a:t>Ett bleck som saknas</a:t>
             </a:r>
           </a:p>
         </p:txBody>
@@ -10938,7 +10757,7 @@
                 <a:ea typeface="Calibri"/>
                 <a:cs typeface="Calibri"/>
               </a:rPr>
-              <a:t>I hållkretsen är S0 sluten, S1 öppen och K1 opåverkad. Finns en sluten strömväg till K1-spolen?</a:t>
+              <a:t>Blecken ska ligga för Δ. Du mäter U1–V1 = 4,2 Ω, V1–W1 = 4,2 Ω och W1–U1 = 8,4 Ω. En lindning har resistansen 4,2 Ω. Vad visar mätningen, och vilket bleck saknas?</a:t>
             </a:r>
           </a:p>
         </p:txBody>
@@ -11061,7 +10880,7 @@
       </p:sp>
       <p:pic xmlns:a="http://schemas.openxmlformats.org/drawingml/2006/main" xmlns:r="http://schemas.openxmlformats.org/officeDocument/2006/relationships">
         <p:nvPicPr>
-          <p:cNvPr id="9" name="Figur: Hållkrets i vila: S0 sluten, S1 öppen, K" descr="Hållkrets i vila: S0 sluten, S1 öppen, K1:s hållkontakt öppen"/>
+          <p:cNvPr id="9" name="Figur: Stapeldiagram i Δ: U1–V1 4,2 ohm, V1–W1 4,2 ohm, W1–U" descr="Stapeldiagram i Δ: U1–V1 4,2 ohm, V1–W1 4,2 ohm, W1–U1 8,4 ohm; vilket bleck som saknas efterfrågas"/>
           <p:cNvPicPr>
             <a:picLocks noChangeAspect="1"/>
           </p:cNvPicPr>
@@ -11238,7 +11057,7 @@
                 <a:ea typeface="Calibri"/>
                 <a:cs typeface="Calibri"/>
               </a:rPr>
-              <a:t>K1:s NO-kontakt följer K1-spolen</a:t>
+              <a:t>NO: öppen i vila. NC: sluten i vila</a:t>
             </a:r>
           </a:p>
         </p:txBody>
@@ -11295,7 +11114,7 @@
                 <a:ea typeface="Calibri"/>
                 <a:cs typeface="Calibri"/>
               </a:rPr>
-              <a:t>När spolen drar sluter dess NO-kontakt. Kontakten ligger parallellt med START och kan hålla kvar strömvägen.</a:t>
+              <a:t>13–14 är kontaktorns hjälpkontakt. 95–96 sitter på överlastreläet.</a:t>
             </a:r>
           </a:p>
         </p:txBody>
@@ -11352,7 +11171,7 @@
                 <a:ea typeface="Calibri"/>
                 <a:cs typeface="Calibri"/>
               </a:rPr>
-              <a:t>Förutsättningar: S0 och returen är hela. S1 hålls in tills K1 hinner dra.</a:t>
+              <a:t>Förutsättningar: Startaren är ett övningsobjekt och är aldrig ansluten. Kontaktorn är opåverkad.</a:t>
             </a:r>
           </a:p>
         </p:txBody>
@@ -11409,7 +11228,7 @@
                 <a:ea typeface="Calibri"/>
                 <a:cs typeface="Calibri"/>
               </a:rPr>
-              <a:t>Arbetsgång: Följ strömvägen medan START hålls in och efter att den släppts. Beskriv hur kontakterna ändrar läge.</a:t>
+              <a:t>Arbetsgång: Bestäm om varje kontakt är normalt öppen eller normalt sluten, och vad testknappen gör med överlastreläet.</a:t>
             </a:r>
           </a:p>
         </p:txBody>
@@ -11628,7 +11447,7 @@
                 <a:ea typeface="Calibri"/>
                 <a:cs typeface="Calibri"/>
               </a:rPr>
-              <a:t>Hållkretsens start</a:t>
+              <a:t>Startarens kontakter</a:t>
             </a:r>
           </a:p>
         </p:txBody>
@@ -11686,7 +11505,7 @@
                 <a:ea typeface="Calibri"/>
                 <a:cs typeface="Calibri"/>
               </a:rPr>
-              <a:t>S1 trycks in och K1 drar. Vad ska K1:s NO-hjälpkontakt göra och varför?</a:t>
+              <a:t>Spänningslöst visar 13–14 överområde och 95–96 0,1 Ω. Vad betyder värdena? Vad visar 95–96 efter överlastreläets testknapp, och varför?</a:t>
             </a:r>
           </a:p>
         </p:txBody>
@@ -11809,7 +11628,7 @@
       </p:sp>
       <p:pic xmlns:a="http://schemas.openxmlformats.org/drawingml/2006/main" xmlns:r="http://schemas.openxmlformats.org/officeDocument/2006/relationships">
         <p:nvPicPr>
-          <p:cNvPr id="9" name="Figur: Hållkrets med START intryckt och K1 drag" descr="Hållkrets med START intryckt och K1 dragen; hållkontaktens läge efterfrågas"/>
+          <p:cNvPr id="9" name="Figur: Startarens kontakter spänningslöst: 13–14 visar övero" descr="Startarens kontakter spänningslöst: 13–14 visar överområde, 95–96 visar 0,1 ohm; läget efter testknappen efterfrågas"/>
           <p:cNvPicPr>
             <a:picLocks noChangeAspect="1"/>
           </p:cNvPicPr>
@@ -11824,7 +11643,7 @@
         <p:spPr>
           <a:xfrm>
             <a:off x="4846320" y="2331720"/>
-            <a:ext cx="3931920" cy="2740984"/>
+            <a:ext cx="3931920" cy="2051585"/>
           </a:xfrm>
           <a:prstGeom prst="rect">
             <a:avLst/>
@@ -11986,7 +11805,52 @@
                 <a:ea typeface="Calibri"/>
                 <a:cs typeface="Calibri"/>
               </a:rPr>
-              <a:t>Hypotes prövas med förväntat kontrollresultat</a:t>
+              <a:t>Nätets U</a:t>
+            </a:r>
+            <a:r>
+              <a:rPr sz="2400" b="1" baseline="-25000">
+                <a:solidFill>
+                  <a:srgbClr val="064F91"/>
+                </a:solidFill>
+                <a:latin typeface="Calibri"/>
+                <a:ea typeface="Calibri"/>
+                <a:cs typeface="Calibri"/>
+              </a:rPr>
+              <a:t>L</a:t>
+            </a:r>
+            <a:r>
+              <a:rPr sz="2400" b="1">
+                <a:solidFill>
+                  <a:srgbClr val="064F91"/>
+                </a:solidFill>
+                <a:latin typeface="Calibri"/>
+                <a:ea typeface="Calibri"/>
+                <a:cs typeface="Calibri"/>
+              </a:rPr>
+              <a:t> = märkvärdet för driftkopplingen</a:t>
+            </a:r>
+          </a:p>
+          <a:p xmlns:a="http://schemas.openxmlformats.org/drawingml/2006/main">
+            <a:pPr algn="l">
+              <a:defRPr sz="2400" b="1">
+                <a:solidFill>
+                  <a:srgbClr val="064F91"/>
+                </a:solidFill>
+                <a:latin typeface="Calibri"/>
+                <a:ea typeface="Calibri"/>
+                <a:cs typeface="Calibri"/>
+              </a:defRPr>
+            </a:pPr>
+            <a:r>
+              <a:rPr sz="2400" b="1">
+                <a:solidFill>
+                  <a:srgbClr val="064F91"/>
+                </a:solidFill>
+                <a:latin typeface="Calibri"/>
+                <a:ea typeface="Calibri"/>
+                <a:cs typeface="Calibri"/>
+              </a:rPr>
+              <a:t>Överlastreläet ställs på märkströmmen för kopplingen</a:t>
             </a:r>
           </a:p>
         </p:txBody>
@@ -12043,7 +11907,7 @@
                 <a:ea typeface="Calibri"/>
                 <a:cs typeface="Calibri"/>
               </a:rPr>
-              <a:t>En hypotes är en möjlig orsak. En kontroll som skiljer mellan orsakerna ger olika resultat för olika orsaker.</a:t>
+              <a:t>Skylten ger strömmen för varje koppling i samma ordning som spänningarna: Δ först, sedan Y.</a:t>
             </a:r>
           </a:p>
         </p:txBody>
@@ -12100,7 +11964,7 @@
                 <a:ea typeface="Calibri"/>
                 <a:cs typeface="Calibri"/>
               </a:rPr>
-              <a:t>Förutsättningar: K1 drar när START hålls in men släpper när knappen släpps. Mätning och omkoppling görs enligt handledarens plan för riggen.</a:t>
+              <a:t>Förutsättningar: Landnät 400 V, 50 Hz. Märkskylt Δ/Y 230/400 V, 5,9/3,4 A, 1,5 kW.</a:t>
             </a:r>
           </a:p>
         </p:txBody>
@@ -12157,7 +12021,7 @@
                 <a:ea typeface="Calibri"/>
                 <a:cs typeface="Calibri"/>
               </a:rPr>
-              <a:t>Arbetsgång: Föreslå en orsak i hållvägen. Beskriv vilken observation som skulle stödja eller försvaga hypotesen.</a:t>
+              <a:t>Arbetsgång: Välj koppling från spänningarna och läs sedan strömmen för den kopplingen.</a:t>
             </a:r>
           </a:p>
         </p:txBody>
@@ -12374,7 +12238,7 @@
                 <a:ea typeface="Calibri"/>
                 <a:cs typeface="Calibri"/>
               </a:rPr>
-              <a:t>Pass 1: 45 minuter</a:t>
+              <a:t>Pass 1: genomgång, 20 minuter</a:t>
             </a:r>
           </a:p>
         </p:txBody>
@@ -12431,7 +12295,7 @@
                 <a:ea typeface="Calibri"/>
                 <a:cs typeface="Calibri"/>
               </a:rPr>
-              <a:t>5 min begrepp, 20 min teori och genomräknade exempel</a:t>
+              <a:t>Labbets ramar, motorns delar, Y och Δ i plinten</a:t>
             </a:r>
           </a:p>
           <a:p xmlns:a="http://schemas.openxmlformats.org/drawingml/2006/main">
@@ -12454,7 +12318,7 @@
                 <a:ea typeface="Calibri"/>
                 <a:cs typeface="Calibri"/>
               </a:rPr>
-              <a:t>15 min övning 3.1, 3.2 och 3.4, 5 min återkoppling</a:t>
+              <a:t>Gemensam förutsägelse: 2R i Y, (2/3) · R i Δ</a:t>
             </a:r>
           </a:p>
         </p:txBody>
@@ -12511,7 +12375,7 @@
                 <a:ea typeface="Calibri"/>
                 <a:cs typeface="Calibri"/>
               </a:rPr>
-              <a:t>Pass 2: 45 minuter</a:t>
+              <a:t>Pass 2: stationerna, 100 minuter</a:t>
             </a:r>
           </a:p>
         </p:txBody>
@@ -12568,7 +12432,7 @@
                 <a:ea typeface="Calibri"/>
                 <a:cs typeface="Calibri"/>
               </a:rPr>
-              <a:t>20 min teori och exempel, 15 min övning 3.6, 3.7 och 3.8</a:t>
+              <a:t>M motorn, S startaren och skylten, T tången: 25 minuter var</a:t>
             </a:r>
           </a:p>
           <a:p xmlns:a="http://schemas.openxmlformats.org/drawingml/2006/main">
@@ -12591,7 +12455,7 @@
                 <a:ea typeface="Calibri"/>
                 <a:cs typeface="Calibri"/>
               </a:rPr>
-              <a:t>8 min lösningsdiskussion, 2 min avslut</a:t>
+              <a:t>Sist resultat på tavlan, protokoll och återkoppling</a:t>
             </a:r>
           </a:p>
         </p:txBody>
@@ -12648,7 +12512,7 @@
                 <a:ea typeface="Calibri"/>
                 <a:cs typeface="Calibri"/>
               </a:rPr>
-              <a:t>Stödbilderna används under arbetet. Övriga övningar: egen studietid.</a:t>
+              <a:t>Förbered övning 3.1–3.5 före träffen. Övning 3.6–3.10 görs efter labbet.</a:t>
             </a:r>
           </a:p>
           <a:p xmlns:a="http://schemas.openxmlformats.org/drawingml/2006/main">
@@ -12671,7 +12535,7 @@
                 <a:ea typeface="Calibri"/>
                 <a:cs typeface="Calibri"/>
               </a:rPr>
-              <a:t>Alla tio med utförlig genomgång: cirka 110–135 min. Paus tillkommer.</a:t>
+              <a:t>Motorn och startaren ansluts aldrig till nätet.</a:t>
             </a:r>
           </a:p>
         </p:txBody>
@@ -12890,7 +12754,7 @@
                 <a:ea typeface="Calibri"/>
                 <a:cs typeface="Calibri"/>
               </a:rPr>
-              <a:t>Förberett fel</a:t>
+              <a:t>Koppling och överlastrelä</a:t>
             </a:r>
           </a:p>
         </p:txBody>
@@ -12948,7 +12812,7 @@
                 <a:ea typeface="Calibri"/>
                 <a:cs typeface="Calibri"/>
               </a:rPr>
-              <a:t>K1 drar medan START hålls in men släpper direkt när knappen släpps. Föreslå en felhypotes och en kontroll som skiljer mellan orsakerna.</a:t>
+              <a:t>Märkskylten anger Δ/Y 230/400 V och 5,9/3,4 A, 1,5 kW, 50 Hz. Motorn ska gå på landnätet 400 V i verkstaden. Vilken koppling ska den ha, och på vilken ström ställs överlastreläet?</a:t>
             </a:r>
           </a:p>
         </p:txBody>
@@ -13071,7 +12935,7 @@
       </p:sp>
       <p:pic xmlns:a="http://schemas.openxmlformats.org/drawingml/2006/main" xmlns:r="http://schemas.openxmlformats.org/officeDocument/2006/relationships">
         <p:nvPicPr>
-          <p:cNvPr id="9" name="Figur: Hållkrets och tidsdiagram: K1 drar med S" descr="Hållkrets och tidsdiagram: K1 drar med START men släpper när START släpps"/>
+          <p:cNvPr id="9" name="Figur: Märkskylt 1,5 kW, Δ/Y 230/400 V, 5,9/3,4 A, 50 Hz och" descr="Märkskylt 1,5 kW, Δ/Y 230/400 V, 5,9/3,4 A, 50 Hz och landnät 400 V; koppling och överlastreläets inställning efterfrågas"/>
           <p:cNvPicPr>
             <a:picLocks noChangeAspect="1"/>
           </p:cNvPicPr>
@@ -13086,7 +12950,7 @@
         <p:spPr>
           <a:xfrm>
             <a:off x="5288447" y="2331720"/>
-            <a:ext cx="3047664" cy="2834640"/>
+            <a:ext cx="3047664" cy="2124559"/>
           </a:xfrm>
           <a:prstGeom prst="rect">
             <a:avLst/>
@@ -13248,118 +13112,7 @@
                 <a:ea typeface="Calibri"/>
                 <a:cs typeface="Calibri"/>
               </a:rPr>
-              <a:t>R</a:t>
-            </a:r>
-            <a:r>
-              <a:rPr sz="2400" b="1" baseline="-25000">
-                <a:solidFill>
-                  <a:srgbClr val="064F91"/>
-                </a:solidFill>
-                <a:latin typeface="Calibri"/>
-                <a:ea typeface="Calibri"/>
-                <a:cs typeface="Calibri"/>
-              </a:rPr>
-              <a:t>min</a:t>
-            </a:r>
-            <a:r>
-              <a:rPr sz="2400" b="1">
-                <a:solidFill>
-                  <a:srgbClr val="064F91"/>
-                </a:solidFill>
-                <a:latin typeface="Calibri"/>
-                <a:ea typeface="Calibri"/>
-                <a:cs typeface="Calibri"/>
-              </a:rPr>
-              <a:t> = R</a:t>
-            </a:r>
-            <a:r>
-              <a:rPr sz="2400" b="1" baseline="-25000">
-                <a:solidFill>
-                  <a:srgbClr val="064F91"/>
-                </a:solidFill>
-                <a:latin typeface="Calibri"/>
-                <a:ea typeface="Calibri"/>
-                <a:cs typeface="Calibri"/>
-              </a:rPr>
-              <a:t>nom</a:t>
-            </a:r>
-            <a:r>
-              <a:rPr sz="2400" b="1">
-                <a:solidFill>
-                  <a:srgbClr val="064F91"/>
-                </a:solidFill>
-                <a:latin typeface="Calibri"/>
-                <a:ea typeface="Calibri"/>
-                <a:cs typeface="Calibri"/>
-              </a:rPr>
-              <a:t> · (1 − p/100)</a:t>
-            </a:r>
-          </a:p>
-          <a:p xmlns:a="http://schemas.openxmlformats.org/drawingml/2006/main">
-            <a:pPr algn="l">
-              <a:defRPr sz="2400" b="1">
-                <a:solidFill>
-                  <a:srgbClr val="064F91"/>
-                </a:solidFill>
-                <a:latin typeface="Calibri"/>
-                <a:ea typeface="Calibri"/>
-                <a:cs typeface="Calibri"/>
-              </a:defRPr>
-            </a:pPr>
-            <a:r>
-              <a:rPr sz="2400" b="1">
-                <a:solidFill>
-                  <a:srgbClr val="064F91"/>
-                </a:solidFill>
-                <a:latin typeface="Calibri"/>
-                <a:ea typeface="Calibri"/>
-                <a:cs typeface="Calibri"/>
-              </a:rPr>
-              <a:t>R</a:t>
-            </a:r>
-            <a:r>
-              <a:rPr sz="2400" b="1" baseline="-25000">
-                <a:solidFill>
-                  <a:srgbClr val="064F91"/>
-                </a:solidFill>
-                <a:latin typeface="Calibri"/>
-                <a:ea typeface="Calibri"/>
-                <a:cs typeface="Calibri"/>
-              </a:rPr>
-              <a:t>max</a:t>
-            </a:r>
-            <a:r>
-              <a:rPr sz="2400" b="1">
-                <a:solidFill>
-                  <a:srgbClr val="064F91"/>
-                </a:solidFill>
-                <a:latin typeface="Calibri"/>
-                <a:ea typeface="Calibri"/>
-                <a:cs typeface="Calibri"/>
-              </a:rPr>
-              <a:t> = R</a:t>
-            </a:r>
-            <a:r>
-              <a:rPr sz="2400" b="1" baseline="-25000">
-                <a:solidFill>
-                  <a:srgbClr val="064F91"/>
-                </a:solidFill>
-                <a:latin typeface="Calibri"/>
-                <a:ea typeface="Calibri"/>
-                <a:cs typeface="Calibri"/>
-              </a:rPr>
-              <a:t>nom</a:t>
-            </a:r>
-            <a:r>
-              <a:rPr sz="2400" b="1">
-                <a:solidFill>
-                  <a:srgbClr val="064F91"/>
-                </a:solidFill>
-                <a:latin typeface="Calibri"/>
-                <a:ea typeface="Calibri"/>
-                <a:cs typeface="Calibri"/>
-              </a:rPr>
-              <a:t> · (1 + p/100)</a:t>
+              <a:t>Tången visar summan av strömmarna genom käften</a:t>
             </a:r>
           </a:p>
         </p:txBody>
@@ -13416,29 +13169,7 @@
                 <a:ea typeface="Calibri"/>
                 <a:cs typeface="Calibri"/>
               </a:rPr>
-              <a:t>R</a:t>
-            </a:r>
-            <a:r>
-              <a:rPr sz="2100" b="0" baseline="-25000">
-                <a:solidFill>
-                  <a:srgbClr val="111111"/>
-                </a:solidFill>
-                <a:latin typeface="Calibri"/>
-                <a:ea typeface="Calibri"/>
-                <a:cs typeface="Calibri"/>
-              </a:rPr>
-              <a:t>nom</a:t>
-            </a:r>
-            <a:r>
-              <a:rPr sz="2100" b="0">
-                <a:solidFill>
-                  <a:srgbClr val="111111"/>
-                </a:solidFill>
-                <a:latin typeface="Calibri"/>
-                <a:ea typeface="Calibri"/>
-                <a:cs typeface="Calibri"/>
-              </a:rPr>
-              <a:t> är det nominella värdet och p toleransen i procent. Ett värde precis på gränsen är godkänt.</a:t>
+              <a:t>Varje gång sladden passerar käften räknas strömmen en gång, med sin riktning.</a:t>
             </a:r>
           </a:p>
         </p:txBody>
@@ -13495,29 +13226,7 @@
                 <a:ea typeface="Calibri"/>
                 <a:cs typeface="Calibri"/>
               </a:rPr>
-              <a:t>Förutsättningar: R</a:t>
-            </a:r>
-            <a:r>
-              <a:rPr sz="2025" b="0" baseline="-25000">
-                <a:solidFill>
-                  <a:srgbClr val="111111"/>
-                </a:solidFill>
-                <a:latin typeface="Calibri"/>
-                <a:ea typeface="Calibri"/>
-                <a:cs typeface="Calibri"/>
-              </a:rPr>
-              <a:t>nom</a:t>
-            </a:r>
-            <a:r>
-              <a:rPr sz="2025" b="0">
-                <a:solidFill>
-                  <a:srgbClr val="111111"/>
-                </a:solidFill>
-                <a:latin typeface="Calibri"/>
-                <a:ea typeface="Calibri"/>
-                <a:cs typeface="Calibri"/>
-              </a:rPr>
-              <a:t> = 1 kΩ, p = 5, uppmätt 1,03 kΩ. Instrumentets fel räknas inte med.</a:t>
+              <a:t>Förutsättningar: Tångstationen på skyddsklenspänning. Tången nollställd i läget DC A. Strömmen 1,8 A.</a:t>
             </a:r>
           </a:p>
         </p:txBody>
@@ -13574,7 +13283,7 @@
                 <a:ea typeface="Calibri"/>
                 <a:cs typeface="Calibri"/>
               </a:rPr>
-              <a:t>Arbetsgång: Räkna ut nedre och övre gräns och jämför mätvärdet med båda.</a:t>
+              <a:t>Arbetsgång: Räkna hur många gånger strömmen passerar käften och åt vilket håll.</a:t>
             </a:r>
           </a:p>
         </p:txBody>
@@ -13793,7 +13502,7 @@
                 <a:ea typeface="Calibri"/>
                 <a:cs typeface="Calibri"/>
               </a:rPr>
-              <a:t>Mätvärde med avvikelse</a:t>
+              <a:t>Tången med flera varv</a:t>
             </a:r>
           </a:p>
         </p:txBody>
@@ -13851,7 +13560,7 @@
                 <a:ea typeface="Calibri"/>
                 <a:cs typeface="Calibri"/>
               </a:rPr>
-              <a:t>En 1 kΩ-resistor med tolerans ±5 % mäts till 1,03 kΩ. Bortse från instrumentets fel. Ligger värdet inom toleransen?</a:t>
+              <a:t>Ett DC-aggregat driver 1,8 A genom en labbsladd. Vad visar tången med sladden två varv genom käften, och med sladden vikt som en hårnål?</a:t>
             </a:r>
           </a:p>
         </p:txBody>
@@ -13974,7 +13683,7 @@
       </p:sp>
       <p:pic xmlns:a="http://schemas.openxmlformats.org/drawingml/2006/main" xmlns:r="http://schemas.openxmlformats.org/officeDocument/2006/relationships">
         <p:nvPicPr>
-          <p:cNvPr id="9" name="Figur: Toleransband plus minus 5 procent kring " descr="Toleransband plus minus 5 procent kring 1 kiloohm; uppmätt 1,03 kiloohm"/>
+          <p:cNvPr id="9" name="Figur: Strömtång med sladden två varv och som hårnål, 1,8 A " descr="Strömtång med sladden två varv och som hårnål, 1,8 A i sladden; visat värde efterfrågas"/>
           <p:cNvPicPr>
             <a:picLocks noChangeAspect="1"/>
           </p:cNvPicPr>
@@ -13989,7 +13698,7 @@
         <p:spPr>
           <a:xfrm>
             <a:off x="4846320" y="2331720"/>
-            <a:ext cx="3931920" cy="2740984"/>
+            <a:ext cx="3931920" cy="2557763"/>
           </a:xfrm>
           <a:prstGeom prst="rect">
             <a:avLst/>
@@ -14151,7 +13860,73 @@
                 <a:ea typeface="Calibri"/>
                 <a:cs typeface="Calibri"/>
               </a:rPr>
-              <a:t>Slutsats kopplas till data och driftfall</a:t>
+              <a:t>I</a:t>
+            </a:r>
+            <a:r>
+              <a:rPr sz="2400" b="1" baseline="-25000">
+                <a:solidFill>
+                  <a:srgbClr val="064F91"/>
+                </a:solidFill>
+                <a:latin typeface="Calibri"/>
+                <a:ea typeface="Calibri"/>
+                <a:cs typeface="Calibri"/>
+              </a:rPr>
+              <a:t>1</a:t>
+            </a:r>
+            <a:r>
+              <a:rPr sz="2400" b="1">
+                <a:solidFill>
+                  <a:srgbClr val="064F91"/>
+                </a:solidFill>
+                <a:latin typeface="Calibri"/>
+                <a:ea typeface="Calibri"/>
+                <a:cs typeface="Calibri"/>
+              </a:rPr>
+              <a:t> + I</a:t>
+            </a:r>
+            <a:r>
+              <a:rPr sz="2400" b="1" baseline="-25000">
+                <a:solidFill>
+                  <a:srgbClr val="064F91"/>
+                </a:solidFill>
+                <a:latin typeface="Calibri"/>
+                <a:ea typeface="Calibri"/>
+                <a:cs typeface="Calibri"/>
+              </a:rPr>
+              <a:t>2</a:t>
+            </a:r>
+            <a:r>
+              <a:rPr sz="2400" b="1">
+                <a:solidFill>
+                  <a:srgbClr val="064F91"/>
+                </a:solidFill>
+                <a:latin typeface="Calibri"/>
+                <a:ea typeface="Calibri"/>
+                <a:cs typeface="Calibri"/>
+              </a:rPr>
+              <a:t> + I</a:t>
+            </a:r>
+            <a:r>
+              <a:rPr sz="2400" b="1" baseline="-25000">
+                <a:solidFill>
+                  <a:srgbClr val="064F91"/>
+                </a:solidFill>
+                <a:latin typeface="Calibri"/>
+                <a:ea typeface="Calibri"/>
+                <a:cs typeface="Calibri"/>
+              </a:rPr>
+              <a:t>3</a:t>
+            </a:r>
+            <a:r>
+              <a:rPr sz="2400" b="1">
+                <a:solidFill>
+                  <a:srgbClr val="064F91"/>
+                </a:solidFill>
+                <a:latin typeface="Calibri"/>
+                <a:ea typeface="Calibri"/>
+                <a:cs typeface="Calibri"/>
+              </a:rPr>
+              <a:t> = 0 vid symmetri utan neutralledare</a:t>
             </a:r>
           </a:p>
         </p:txBody>
@@ -14208,7 +13983,7 @@
                 <a:ea typeface="Calibri"/>
                 <a:cs typeface="Calibri"/>
               </a:rPr>
-              <a:t>En slutsats ska ange vad jämförelsen visar. Mätvillkor och kvarstående osäkerhet avgränsar slutsatsen.</a:t>
+              <a:t>Tången visar summan av strömmarna genom käften. En hel kabel har alla tre fasledarna i käften.</a:t>
             </a:r>
           </a:p>
         </p:txBody>
@@ -14265,7 +14040,7 @@
                 <a:ea typeface="Calibri"/>
                 <a:cs typeface="Calibri"/>
               </a:rPr>
-              <a:t>Förutsättningar: Källan 11,94 V och spänningsfallen 3,98 V och 7,96 V är givna övningsdata.</a:t>
+              <a:t>Förutsättningar: Ombord, 440 V, 60 Hz. Trefasmotor utan neutralledare. Tången är avsedd för mätningen och mätkategorin.</a:t>
             </a:r>
           </a:p>
         </p:txBody>
@@ -14322,7 +14097,7 @@
                 <a:ea typeface="Calibri"/>
                 <a:cs typeface="Calibri"/>
               </a:rPr>
-              <a:t>Arbetsgång: Visa summan och jämför med källan. Vad visar jämförelsen, och vad visar den inte?</a:t>
+              <a:t>Arbetsgång: Använd summan av fasströmmarna från Del 1 och det du såg med hårnålen på tångstationen.</a:t>
             </a:r>
           </a:p>
         </p:txBody>
@@ -14541,7 +14316,7 @@
                 <a:ea typeface="Calibri"/>
                 <a:cs typeface="Calibri"/>
               </a:rPr>
-              <a:t>Egen slutsats</a:t>
+              <a:t>Tången runt motorkabeln</a:t>
             </a:r>
           </a:p>
         </p:txBody>
@@ -14599,7 +14374,7 @@
                 <a:ea typeface="Calibri"/>
                 <a:cs typeface="Calibri"/>
               </a:rPr>
-              <a:t>Skriv en kort slutsats till protokollet: källan mäts till 11,94 V och seriekretsens spänningsfall är 3,98 och 7,96 V.</a:t>
+              <a:t>En motorman lägger tången runt hela kabeln till en trefasmotor ombord medan den går, och läser 0,2 A. Förklara varför värdet är så litet, och hur fasströmmen ska mätas.</a:t>
             </a:r>
           </a:p>
         </p:txBody>
@@ -14722,7 +14497,7 @@
       </p:sp>
       <p:pic xmlns:a="http://schemas.openxmlformats.org/drawingml/2006/main" xmlns:r="http://schemas.openxmlformats.org/officeDocument/2006/relationships">
         <p:nvPicPr>
-          <p:cNvPr id="9" name="Figur: Seriekrets där källan mäts till 11,94 V " descr="Seriekrets där källan mäts till 11,94 V och spänningsfallen till 3,98 och 7,96 V"/>
+          <p:cNvPr id="9" name="Figur: Tång runt hela trefaskabeln till en motor ombord visa" descr="Tång runt hela trefaskabeln till en motor ombord visar 0,2 A; förklaring och rätt mätsätt efterfrågas"/>
           <p:cNvPicPr>
             <a:picLocks noChangeAspect="1"/>
           </p:cNvPicPr>
@@ -14901,7 +14676,7 @@
                 <a:ea typeface="Calibri"/>
                 <a:cs typeface="Calibri"/>
               </a:rPr>
-              <a:t>Vilken slutsats kan ditt protokoll stödja, och vad har du ännu inte kontrollerat?</a:t>
+              <a:t>Vilken koppling visar dina mätvärden, och hur vet du det?</a:t>
             </a:r>
           </a:p>
         </p:txBody>
@@ -14959,7 +14734,7 @@
                 <a:ea typeface="Calibri"/>
                 <a:cs typeface="Calibri"/>
               </a:rPr>
-              <a:t>Färdigställ individuellt protokoll. Praktisk bedömning och eventuella kompletteringar följer lärarens separata plan för träffen.</a:t>
+              <a:t>Gör klart ditt protokoll och lämna in det med veckans uppgifter senast söndag 11 oktober.</a:t>
             </a:r>
           </a:p>
         </p:txBody>
@@ -15203,7 +14978,7 @@
                 <a:ea typeface="Calibri"/>
                 <a:cs typeface="Calibri"/>
               </a:rPr>
-              <a:t>Sjöskolans kursmaterial och originalmall</a:t>
+              <a:t>Laborationsunderlag och inköpsguide, 24 september 2026</a:t>
             </a:r>
           </a:p>
         </p:txBody>
@@ -15260,9 +15035,8 @@
                 <a:latin typeface="Calibri"/>
                 <a:ea typeface="Calibri"/>
                 <a:cs typeface="Calibri"/>
-                <a:hlinkClick xmlns:r="http://schemas.openxmlformats.org/officeDocument/2006/relationships" r:id="Readafdc350414a8a"/>
-              </a:rPr>
-              <a:t>Fluke: multimeterns funktioner och mätning</a:t>
+              </a:rPr>
+              <a:t>Motorns märkskylt och dokumentation</a:t>
             </a:r>
           </a:p>
         </p:txBody>
@@ -15319,9 +15093,8 @@
                 <a:latin typeface="Calibri"/>
                 <a:ea typeface="Calibri"/>
                 <a:cs typeface="Calibri"/>
-                <a:hlinkClick xmlns:r="http://schemas.openxmlformats.org/officeDocument/2006/relationships" r:id="R326d635f80904509"/>
-              </a:rPr>
-              <a:t>SEK: SS-EN 50110-1, utgåva 4:2024</a:t>
+              </a:rPr>
+              <a:t>Startarens kopplingsschema för vald modell</a:t>
             </a:r>
           </a:p>
         </p:txBody>
@@ -15378,9 +15151,8 @@
                 <a:latin typeface="Calibri"/>
                 <a:ea typeface="Calibri"/>
                 <a:cs typeface="Calibri"/>
-                <a:hlinkClick xmlns:r="http://schemas.openxmlformats.org/officeDocument/2006/relationships" r:id="R304cd51401e44174"/>
-              </a:rPr>
-              <a:t>Schneider Electric: skenbar effekt</a:t>
+              </a:rPr>
+              <a:t>UNI-T UT210D: bruksanvisning för tångmätning</a:t>
             </a:r>
           </a:p>
         </p:txBody>
@@ -15541,7 +15313,7 @@
                 <a:ea typeface="Calibri"/>
                 <a:cs typeface="Calibri"/>
               </a:rPr>
-              <a:t>Beräkning före mätning</a:t>
+              <a:t>Labbets ramar</a:t>
             </a:r>
           </a:p>
         </p:txBody>
@@ -15598,7 +15370,7 @@
                 <a:ea typeface="Calibri"/>
                 <a:cs typeface="Calibri"/>
               </a:rPr>
-              <a:t>Förväntat värde kommer från schema, märkdata och angiven modell.</a:t>
+              <a:t>Motorn och startaren är övningsobjekt. De ansluts aldrig till nätet.</a:t>
             </a:r>
           </a:p>
         </p:txBody>
@@ -15655,7 +15427,7 @@
                 <a:ea typeface="Calibri"/>
                 <a:cs typeface="Calibri"/>
               </a:rPr>
-              <a:t>Mätvärde kräver två mätpunkter, instrument och driftläge.</a:t>
+              <a:t>Blecken flyttas med mätsladdarna bortkopplade.</a:t>
             </a:r>
           </a:p>
         </p:txBody>
@@ -15712,7 +15484,7 @@
                 <a:ea typeface="Calibri"/>
                 <a:cs typeface="Calibri"/>
               </a:rPr>
-              <a:t>Avvikelse är uppmätt minus förväntat värde.</a:t>
+              <a:t>Tångstationen matas av ett strömbegränsat DC-aggregat på skyddsklenspänning.</a:t>
             </a:r>
           </a:p>
         </p:txBody>
@@ -15769,7 +15541,7 @@
                 <a:ea typeface="Calibri"/>
                 <a:cs typeface="Calibri"/>
               </a:rPr>
-              <a:t>En slutsats behöver ta hänsyn till tolerans och instrumentets bidrag.</a:t>
+              <a:t>Förutsäg först, mät sedan, jämför och förklara skillnaden.</a:t>
             </a:r>
           </a:p>
         </p:txBody>
@@ -16455,7 +16227,7 @@
                 <a:ea typeface="Calibri"/>
                 <a:cs typeface="Calibri"/>
               </a:rPr>
-              <a:t>Ramar för stationspasset</a:t>
+              <a:t>Motorns delar och märkskylt</a:t>
             </a:r>
           </a:p>
         </p:txBody>
@@ -16477,7 +16249,7 @@
         <p:spPr>
           <a:xfrm xmlns:a="http://schemas.openxmlformats.org/drawingml/2006/main">
             <a:off x="762000" y="1619250"/>
-            <a:ext cx="7620000" cy="1466850"/>
+            <a:ext cx="3977639" cy="1466850"/>
           </a:xfrm>
           <a:prstGeom xmlns:a="http://schemas.openxmlformats.org/drawingml/2006/main" prst="rect">
             <a:avLst/>
@@ -16505,15 +16277,15 @@
               </a:defRPr>
             </a:pPr>
             <a:r>
-              <a:rPr sz="2400" b="0">
-                <a:solidFill>
-                  <a:srgbClr val="111111"/>
-                </a:solidFill>
-                <a:latin typeface="Calibri"/>
-                <a:ea typeface="Calibri"/>
-                <a:cs typeface="Calibri"/>
-              </a:rPr>
-              <a:t>Instruktören kontrollerar rigg, strömgräns och instrument.</a:t>
+              <a:rPr sz="1800" b="0">
+                <a:solidFill>
+                  <a:srgbClr val="111111"/>
+                </a:solidFill>
+                <a:latin typeface="Calibri"/>
+                <a:ea typeface="Calibri"/>
+                <a:cs typeface="Calibri"/>
+              </a:rPr>
+              <a:t>Statorn sitter i stommen. Rotorn på axeln bärs av lager.</a:t>
             </a:r>
           </a:p>
           <a:p xmlns:a="http://schemas.openxmlformats.org/drawingml/2006/main">
@@ -16529,15 +16301,15 @@
               </a:defRPr>
             </a:pPr>
             <a:r>
-              <a:rPr sz="2400" b="0">
-                <a:solidFill>
-                  <a:srgbClr val="111111"/>
-                </a:solidFill>
-                <a:latin typeface="Calibri"/>
-                <a:ea typeface="Calibri"/>
-                <a:cs typeface="Calibri"/>
-              </a:rPr>
-              <a:t>Elevpraktik sker på avsedd SELV-utrustning eller spänningslöst.</a:t>
+              <a:rPr sz="1800" b="0">
+                <a:solidFill>
+                  <a:srgbClr val="111111"/>
+                </a:solidFill>
+                <a:latin typeface="Calibri"/>
+                <a:ea typeface="Calibri"/>
+                <a:cs typeface="Calibri"/>
+              </a:rPr>
+              <a:t>Fläkten kyler genom flänsarna.</a:t>
             </a:r>
           </a:p>
         </p:txBody>
@@ -16559,7 +16331,7 @@
         <p:spPr>
           <a:xfrm xmlns:a="http://schemas.openxmlformats.org/drawingml/2006/main">
             <a:off x="762000" y="3200400"/>
-            <a:ext cx="7620000" cy="838200"/>
+            <a:ext cx="3977639" cy="838200"/>
           </a:xfrm>
           <a:prstGeom xmlns:a="http://schemas.openxmlformats.org/drawingml/2006/main" prst="rect">
             <a:avLst/>
@@ -16587,7 +16359,7 @@
               </a:defRPr>
             </a:pPr>
             <a:r>
-              <a:rPr sz="2925" b="1">
+              <a:rPr sz="2650" b="1">
                 <a:solidFill>
                   <a:srgbClr val="064F91"/>
                 </a:solidFill>
@@ -16595,7 +16367,7 @@
                 <a:ea typeface="Calibri"/>
                 <a:cs typeface="Calibri"/>
               </a:rPr>
-              <a:t>Klartecken före energisättning</a:t>
+              <a:t>Märkskylten avgör kopplingen</a:t>
             </a:r>
           </a:p>
         </p:txBody>
@@ -16617,7 +16389,7 @@
         <p:spPr>
           <a:xfrm xmlns:a="http://schemas.openxmlformats.org/drawingml/2006/main">
             <a:off x="762000" y="4429125"/>
-            <a:ext cx="7620000" cy="1352550"/>
+            <a:ext cx="3977639" cy="1352550"/>
           </a:xfrm>
           <a:prstGeom xmlns:a="http://schemas.openxmlformats.org/drawingml/2006/main" prst="rect">
             <a:avLst/>
@@ -16645,15 +16417,15 @@
               </a:defRPr>
             </a:pPr>
             <a:r>
-              <a:rPr sz="2250" b="0">
-                <a:solidFill>
-                  <a:srgbClr val="111111"/>
-                </a:solidFill>
-                <a:latin typeface="Calibri"/>
-                <a:ea typeface="Calibri"/>
-                <a:cs typeface="Calibri"/>
-              </a:rPr>
-              <a:t>Omkoppling sker frånskilt. Avbryt vid skada, värme eller osäkerhet.</a:t>
+              <a:rPr sz="1800" b="0">
+                <a:solidFill>
+                  <a:srgbClr val="111111"/>
+                </a:solidFill>
+                <a:latin typeface="Calibri"/>
+                <a:ea typeface="Calibri"/>
+                <a:cs typeface="Calibri"/>
+              </a:rPr>
+              <a:t>Skylten anger effekt, Δ/Y-spänning, ström, cos φ, varvtal och frekvens.</a:t>
             </a:r>
           </a:p>
           <a:p xmlns:a="http://schemas.openxmlformats.org/drawingml/2006/main">
@@ -16669,15 +16441,15 @@
               </a:defRPr>
             </a:pPr>
             <a:r>
-              <a:rPr sz="2250" b="0">
-                <a:solidFill>
-                  <a:srgbClr val="111111"/>
-                </a:solidFill>
-                <a:latin typeface="Calibri"/>
-                <a:ea typeface="Calibri"/>
-                <a:cs typeface="Calibri"/>
-              </a:rPr>
-              <a:t>Trefasmätning kräver en avsedd, dokumenterad rigg.</a:t>
+              <a:rPr sz="1800" b="0">
+                <a:solidFill>
+                  <a:srgbClr val="111111"/>
+                </a:solidFill>
+                <a:latin typeface="Calibri"/>
+                <a:ea typeface="Calibri"/>
+                <a:cs typeface="Calibri"/>
+              </a:rPr>
+              <a:t>Ombord ofta 440 V, 60 Hz: kontrollera skylten.</a:t>
             </a:r>
           </a:p>
         </p:txBody>
@@ -16740,6 +16512,30 @@
           </a:p>
         </p:txBody>
       </p:sp>
+      <p:pic xmlns:a="http://schemas.openxmlformats.org/drawingml/2006/main" xmlns:r="http://schemas.openxmlformats.org/officeDocument/2006/relationships">
+        <p:nvPicPr>
+          <p:cNvPr id="9" name="Figur: Trefasmotor från sidan: kopplingslåda me" descr="Trefasmotor från sidan: kopplingslåda med plint, fläktkåpa med fläkt, stomme med kylflänsar, lagersköldar, axel med kil, märkskylt och fötter"/>
+          <p:cNvPicPr>
+            <a:picLocks noChangeAspect="1"/>
+          </p:cNvPicPr>
+          <p:nvPr/>
+        </p:nvPicPr>
+        <p:blipFill>
+          <a:blip r:embed="rId3"/>
+          <a:stretch>
+            <a:fillRect/>
+          </a:stretch>
+        </p:blipFill>
+        <p:spPr>
+          <a:xfrm>
+            <a:off x="4892040" y="1645920"/>
+            <a:ext cx="3886200" cy="2532123"/>
+          </a:xfrm>
+          <a:prstGeom prst="rect">
+            <a:avLst/>
+          </a:prstGeom>
+        </p:spPr>
+      </p:pic>
     </p:spTree>
     <p:extLst>
       <p:ext uri="{BB962C8B-B14F-4D97-AF65-F5344CB8AC3E}">
@@ -16839,7 +16635,7 @@
                 <a:ea typeface="Calibri"/>
                 <a:cs typeface="Calibri"/>
               </a:rPr>
-              <a:t>Station A: DC-delare</a:t>
+              <a:t>Lindningar och plint</a:t>
             </a:r>
           </a:p>
         </p:txBody>
@@ -16897,7 +16693,7 @@
                 <a:ea typeface="Calibri"/>
                 <a:cs typeface="Calibri"/>
               </a:rPr>
-              <a:t>12 V DC matar 1 kΩ och 2 kΩ i serie.</a:t>
+              <a:t>Tre lindningar: U1–U2, V1–V2 och W1–W2.</a:t>
             </a:r>
           </a:p>
           <a:p xmlns:a="http://schemas.openxmlformats.org/drawingml/2006/main">
@@ -16921,7 +16717,7 @@
                 <a:ea typeface="Calibri"/>
                 <a:cs typeface="Calibri"/>
               </a:rPr>
-              <a:t>Förutsäg ström och spänningsfall före mätningen.</a:t>
+              <a:t>Utan bleck är lindningarna skilda åt.</a:t>
             </a:r>
           </a:p>
         </p:txBody>
@@ -16979,7 +16775,62 @@
                 <a:ea typeface="Calibri"/>
                 <a:cs typeface="Calibri"/>
               </a:rPr>
-              <a:t>I = U/(R₁ + R₂)</a:t>
+              <a:t>R</a:t>
+            </a:r>
+            <a:r>
+              <a:rPr sz="2925" b="1" baseline="-25000">
+                <a:solidFill>
+                  <a:srgbClr val="064F91"/>
+                </a:solidFill>
+                <a:latin typeface="Calibri"/>
+                <a:ea typeface="Calibri"/>
+                <a:cs typeface="Calibri"/>
+              </a:rPr>
+              <a:t>U1–U2</a:t>
+            </a:r>
+            <a:r>
+              <a:rPr sz="2925" b="1">
+                <a:solidFill>
+                  <a:srgbClr val="064F91"/>
+                </a:solidFill>
+                <a:latin typeface="Calibri"/>
+                <a:ea typeface="Calibri"/>
+                <a:cs typeface="Calibri"/>
+              </a:rPr>
+              <a:t> ≈ R</a:t>
+            </a:r>
+            <a:r>
+              <a:rPr sz="2925" b="1" baseline="-25000">
+                <a:solidFill>
+                  <a:srgbClr val="064F91"/>
+                </a:solidFill>
+                <a:latin typeface="Calibri"/>
+                <a:ea typeface="Calibri"/>
+                <a:cs typeface="Calibri"/>
+              </a:rPr>
+              <a:t>V1–V2</a:t>
+            </a:r>
+            <a:r>
+              <a:rPr sz="2925" b="1">
+                <a:solidFill>
+                  <a:srgbClr val="064F91"/>
+                </a:solidFill>
+                <a:latin typeface="Calibri"/>
+                <a:ea typeface="Calibri"/>
+                <a:cs typeface="Calibri"/>
+              </a:rPr>
+              <a:t> ≈ R</a:t>
+            </a:r>
+            <a:r>
+              <a:rPr sz="2925" b="1" baseline="-25000">
+                <a:solidFill>
+                  <a:srgbClr val="064F91"/>
+                </a:solidFill>
+                <a:latin typeface="Calibri"/>
+                <a:ea typeface="Calibri"/>
+                <a:cs typeface="Calibri"/>
+              </a:rPr>
+              <a:t>W1–W2</a:t>
             </a:r>
           </a:p>
         </p:txBody>
@@ -17037,7 +16888,7 @@
                 <a:ea typeface="Calibri"/>
                 <a:cs typeface="Calibri"/>
               </a:rPr>
-              <a:t>Beräkna I och U₂ i övning 3.2 före mätningen.</a:t>
+              <a:t>Mellan två olika lindningar visar mätaren överområde.</a:t>
             </a:r>
           </a:p>
           <a:p xmlns:a="http://schemas.openxmlformats.org/drawingml/2006/main">
@@ -17061,7 +16912,7 @@
                 <a:ea typeface="Calibri"/>
                 <a:cs typeface="Calibri"/>
               </a:rPr>
-              <a:t>Instruktören granskar mätplan och anslutningar före start.</a:t>
+              <a:t>Dra av mätsladdarnas resistans: en lindning har bara några ohm.</a:t>
             </a:r>
           </a:p>
         </p:txBody>
@@ -17126,7 +16977,7 @@
       </p:sp>
       <p:pic xmlns:a="http://schemas.openxmlformats.org/drawingml/2006/main" xmlns:r="http://schemas.openxmlformats.org/officeDocument/2006/relationships">
         <p:nvPicPr>
-          <p:cNvPr id="9" name="Figur: Station A: 12 V DC matar R1 1 kiloohm oc" descr="Station A: 12 V DC matar R1 1 kiloohm och R2 2 kiloohm i serie"/>
+          <p:cNvPr id="9" name="Figur: Plint med sex lindningsändar utan bleck; lindningarna" descr="Plint med sex lindningsändar utan bleck; lindningarna U1–U2, V1–V2 och W1–W2 streckade; ohmmeter mellan U1 och U2"/>
           <p:cNvPicPr>
             <a:picLocks noChangeAspect="1"/>
           </p:cNvPicPr>
@@ -17247,7 +17098,7 @@
                 <a:ea typeface="Calibri"/>
                 <a:cs typeface="Calibri"/>
               </a:rPr>
-              <a:t>Station B: AC och trefas</a:t>
+              <a:t>Y och Δ med bleck</a:t>
             </a:r>
           </a:p>
         </p:txBody>
@@ -17305,7 +17156,7 @@
                 <a:ea typeface="Calibri"/>
                 <a:cs typeface="Calibri"/>
               </a:rPr>
-              <a:t>Använd avsedd isolerad AC-källa och lämpligt RMS-instrument.</a:t>
+              <a:t>Y: blecken förbinder W2, U2 och V2. Det är stjärnpunkten.</a:t>
             </a:r>
           </a:p>
           <a:p xmlns:a="http://schemas.openxmlformats.org/drawingml/2006/main">
@@ -17329,7 +17180,7 @@
                 <a:ea typeface="Calibri"/>
                 <a:cs typeface="Calibri"/>
               </a:rPr>
-              <a:t>Mät endast vid riggens dokumenterade mätpunkter.</a:t>
+              <a:t>Δ: tre lodräta bleck, U1–W2, V1–U2 och W1–V2.</a:t>
             </a:r>
           </a:p>
         </p:txBody>
@@ -17387,51 +17238,7 @@
                 <a:ea typeface="Calibri"/>
                 <a:cs typeface="Calibri"/>
               </a:rPr>
-              <a:t>U</a:t>
-            </a:r>
-            <a:r>
-              <a:rPr sz="2650" b="1" baseline="-25000">
-                <a:solidFill>
-                  <a:srgbClr val="064F91"/>
-                </a:solidFill>
-                <a:latin typeface="Calibri"/>
-                <a:ea typeface="Calibri"/>
-                <a:cs typeface="Calibri"/>
-              </a:rPr>
-              <a:t>gren</a:t>
-            </a:r>
-            <a:r>
-              <a:rPr sz="2650" b="1">
-                <a:solidFill>
-                  <a:srgbClr val="064F91"/>
-                </a:solidFill>
-                <a:latin typeface="Calibri"/>
-                <a:ea typeface="Calibri"/>
-                <a:cs typeface="Calibri"/>
-              </a:rPr>
-              <a:t> = U</a:t>
-            </a:r>
-            <a:r>
-              <a:rPr sz="2650" b="1" baseline="-25000">
-                <a:solidFill>
-                  <a:srgbClr val="064F91"/>
-                </a:solidFill>
-                <a:latin typeface="Calibri"/>
-                <a:ea typeface="Calibri"/>
-                <a:cs typeface="Calibri"/>
-              </a:rPr>
-              <a:t>L</a:t>
-            </a:r>
-            <a:r>
-              <a:rPr sz="2650" b="1">
-                <a:solidFill>
-                  <a:srgbClr val="064F91"/>
-                </a:solidFill>
-                <a:latin typeface="Calibri"/>
-                <a:ea typeface="Calibri"/>
-                <a:cs typeface="Calibri"/>
-              </a:rPr>
-              <a:t>/√3 i symmetrisk Y</a:t>
+              <a:t>Y: 2R     Δ: (2/3) · R</a:t>
             </a:r>
           </a:p>
         </p:txBody>
@@ -17489,7 +17296,7 @@
                 <a:ea typeface="Calibri"/>
                 <a:cs typeface="Calibri"/>
               </a:rPr>
-              <a:t>Förberedelse: övning 3.4 (AC) och 3.5 (trefas).</a:t>
+              <a:t>Resistansen mellan två plintar kontrollerar kopplingen.</a:t>
             </a:r>
           </a:p>
           <a:p xmlns:a="http://schemas.openxmlformats.org/drawingml/2006/main">
@@ -17513,7 +17320,51 @@
                 <a:ea typeface="Calibri"/>
                 <a:cs typeface="Calibri"/>
               </a:rPr>
-              <a:t>Saknas trefasrigg: räkna på övningsdata eller i Trefaslabbet och dokumentera det som teori.</a:t>
+              <a:t>Kvoten R</a:t>
+            </a:r>
+            <a:r>
+              <a:rPr sz="1700" b="0" baseline="-25000">
+                <a:solidFill>
+                  <a:srgbClr val="111111"/>
+                </a:solidFill>
+                <a:latin typeface="Calibri"/>
+                <a:ea typeface="Calibri"/>
+                <a:cs typeface="Calibri"/>
+              </a:rPr>
+              <a:t>Y</a:t>
+            </a:r>
+            <a:r>
+              <a:rPr sz="1700" b="0">
+                <a:solidFill>
+                  <a:srgbClr val="111111"/>
+                </a:solidFill>
+                <a:latin typeface="Calibri"/>
+                <a:ea typeface="Calibri"/>
+                <a:cs typeface="Calibri"/>
+              </a:rPr>
+              <a:t>/R</a:t>
+            </a:r>
+            <a:r>
+              <a:rPr sz="1700" b="0" baseline="-25000">
+                <a:solidFill>
+                  <a:srgbClr val="111111"/>
+                </a:solidFill>
+                <a:latin typeface="Calibri"/>
+                <a:ea typeface="Calibri"/>
+                <a:cs typeface="Calibri"/>
+              </a:rPr>
+              <a:t>Δ</a:t>
+            </a:r>
+            <a:r>
+              <a:rPr sz="1700" b="0">
+                <a:solidFill>
+                  <a:srgbClr val="111111"/>
+                </a:solidFill>
+                <a:latin typeface="Calibri"/>
+                <a:ea typeface="Calibri"/>
+                <a:cs typeface="Calibri"/>
+              </a:rPr>
+              <a:t> = 3, samma tal som strömmarna i Del 2.</a:t>
             </a:r>
           </a:p>
         </p:txBody>
@@ -17578,7 +17429,7 @@
       </p:sp>
       <p:pic xmlns:a="http://schemas.openxmlformats.org/drawingml/2006/main" xmlns:r="http://schemas.openxmlformats.org/officeDocument/2006/relationships">
         <p:nvPicPr>
-          <p:cNvPr id="9" name="Figur: Station B: symmetrisk Y-last på trefastr" descr="Station B: symmetrisk Y-last på trefastränare med linjespänningen 12 V"/>
+          <p:cNvPr id="9" name="Figur: Resistans mellan U1 och V1: i Y två lindningar i seri" descr="Resistans mellan U1 och V1: i Y två lindningar i serie, 2R; i Δ en lindning parallellt med två i serie, (2/3) · R"/>
           <p:cNvPicPr>
             <a:picLocks noChangeAspect="1"/>
           </p:cNvPicPr>
@@ -17593,7 +17444,7 @@
         <p:spPr>
           <a:xfrm>
             <a:off x="4892040" y="1645920"/>
-            <a:ext cx="3886200" cy="3071293"/>
+            <a:ext cx="3886200" cy="2701382"/>
           </a:xfrm>
           <a:prstGeom prst="rect">
             <a:avLst/>
@@ -17698,7 +17549,7 @@
                 <a:ea typeface="Calibri"/>
                 <a:cs typeface="Calibri"/>
               </a:rPr>
-              <a:t>Exempel: förutsäg en mätning</a:t>
+              <a:t>Exempel: resistansen mellan plintarna</a:t>
             </a:r>
           </a:p>
         </p:txBody>
@@ -17755,7 +17606,7 @@
                 <a:ea typeface="Calibri"/>
                 <a:cs typeface="Calibri"/>
               </a:rPr>
-              <a:t>En kontrollerad 9 V DC-rigg har 1 kΩ och 2 kΩ i serie. Spänning ska mätas över 2 kΩ.</a:t>
+              <a:t>Tre lindningar mäts till 6,0 Ω var, med mätsladdarna avdragna. Förutsäg resistansen mellan U1 och V1 i Y och i Δ.</a:t>
             </a:r>
           </a:p>
         </p:txBody>
@@ -17812,7 +17663,51 @@
                 <a:ea typeface="Calibri"/>
                 <a:cs typeface="Calibri"/>
               </a:rPr>
-              <a:t>I = U/(R₁ + R₂)     U₂ = I · R₂</a:t>
+              <a:t>R</a:t>
+            </a:r>
+            <a:r>
+              <a:rPr sz="2325" b="1" baseline="-25000">
+                <a:solidFill>
+                  <a:srgbClr val="064F91"/>
+                </a:solidFill>
+                <a:latin typeface="Calibri"/>
+                <a:ea typeface="Calibri"/>
+                <a:cs typeface="Calibri"/>
+              </a:rPr>
+              <a:t>Y</a:t>
+            </a:r>
+            <a:r>
+              <a:rPr sz="2325" b="1">
+                <a:solidFill>
+                  <a:srgbClr val="064F91"/>
+                </a:solidFill>
+                <a:latin typeface="Calibri"/>
+                <a:ea typeface="Calibri"/>
+                <a:cs typeface="Calibri"/>
+              </a:rPr>
+              <a:t> = 2R     R</a:t>
+            </a:r>
+            <a:r>
+              <a:rPr sz="2325" b="1" baseline="-25000">
+                <a:solidFill>
+                  <a:srgbClr val="064F91"/>
+                </a:solidFill>
+                <a:latin typeface="Calibri"/>
+                <a:ea typeface="Calibri"/>
+                <a:cs typeface="Calibri"/>
+              </a:rPr>
+              <a:t>Δ</a:t>
+            </a:r>
+            <a:r>
+              <a:rPr sz="2325" b="1">
+                <a:solidFill>
+                  <a:srgbClr val="064F91"/>
+                </a:solidFill>
+                <a:latin typeface="Calibri"/>
+                <a:ea typeface="Calibri"/>
+                <a:cs typeface="Calibri"/>
+              </a:rPr>
+              <a:t> = R · 2R/(3R)</a:t>
             </a:r>
           </a:p>
         </p:txBody>
@@ -17869,7 +17764,7 @@
                 <a:ea typeface="Calibri"/>
                 <a:cs typeface="Calibri"/>
               </a:rPr>
-              <a:t>1. Rtotal = 3 kΩ. I = 9/3 = 3 mA.</a:t>
+              <a:t>1. Y: två lindningar i serie: 2 · 6,0 = 12,0 Ω.</a:t>
             </a:r>
           </a:p>
           <a:p xmlns:a="http://schemas.openxmlformats.org/drawingml/2006/main">
@@ -17892,7 +17787,7 @@
                 <a:ea typeface="Calibri"/>
                 <a:cs typeface="Calibri"/>
               </a:rPr>
-              <a:t>2. U₂ = 3 mA · 2 kΩ = 6 V. U₁ = 3 V.</a:t>
+              <a:t>2. Δ: 6,0 Ω parallellt med 12,0 Ω: 6,0 · 12,0/18,0 = 4,0 Ω.</a:t>
             </a:r>
           </a:p>
           <a:p xmlns:a="http://schemas.openxmlformats.org/drawingml/2006/main">
@@ -17915,7 +17810,7 @@
                 <a:ea typeface="Calibri"/>
                 <a:cs typeface="Calibri"/>
               </a:rPr>
-              <a:t>3. Voltmeter ansluts parallellt över R₂ efter handledarens kontroll.</a:t>
+              <a:t>3. Kvoten: 12,0/4,0 = 3.</a:t>
             </a:r>
           </a:p>
         </p:txBody>
@@ -17972,7 +17867,7 @@
                 <a:ea typeface="Calibri"/>
                 <a:cs typeface="Calibri"/>
               </a:rPr>
-              <a:t>Kontroll: 3 + 6 = 9 V. Protokollet anger rigg, mätpunkter, instrument och driftläge.</a:t>
+              <a:t>Kontroll: kvoten blir 3 för alla R. Ett annat tal tyder på ett fel bleck eller en fel mätpunkt.</a:t>
             </a:r>
           </a:p>
         </p:txBody>

</xml_diff>

<commit_message>
Sjöskolan v41: labbet fredag 11.00–16.00 med 40 minuter per station, felsökningsuppdrag och morgonchecklista
Co-Authored-By: Claude Opus 5.5 <noreply@anthropic.com>
Claude-Session: https://claude.ai/code/session_011V9KjBb53XrDm23Dw58SH3
</commit_message>
<xml_diff>
--- a/sjoskolan/vecka-41/aktuell/v41_03_Fysisk_traff_och_matning_elev.pptx
+++ b/sjoskolan/vecka-41/aktuell/v41_03_Fysisk_traff_och_matning_elev.pptx
@@ -12238,7 +12238,7 @@
                 <a:ea typeface="Calibri"/>
                 <a:cs typeface="Calibri"/>
               </a:rPr>
-              <a:t>Pass 1: genomgång, 20 minuter</a:t>
+              <a:t>09.00–11.00: genomgång av del 3</a:t>
             </a:r>
           </a:p>
         </p:txBody>
@@ -12295,7 +12295,7 @@
                 <a:ea typeface="Calibri"/>
                 <a:cs typeface="Calibri"/>
               </a:rPr>
-              <a:t>Labbets ramar, motorns delar, Y och Δ i plinten</a:t>
+              <a:t>Labbets ramar, motorns delar, Y och Δ i plinten, startaren och tången</a:t>
             </a:r>
           </a:p>
           <a:p xmlns:a="http://schemas.openxmlformats.org/drawingml/2006/main">
@@ -12318,7 +12318,7 @@
                 <a:ea typeface="Calibri"/>
                 <a:cs typeface="Calibri"/>
               </a:rPr>
-              <a:t>Gemensam förutsägelse: 2R i Y, (2/3) · R i Δ</a:t>
+              <a:t>Övning 3.1–3.5 och gemensam förutsägelse: 2R i Y, (2/3) · R i Δ</a:t>
             </a:r>
           </a:p>
         </p:txBody>
@@ -12375,7 +12375,7 @@
                 <a:ea typeface="Calibri"/>
                 <a:cs typeface="Calibri"/>
               </a:rPr>
-              <a:t>Pass 2: stationerna, 100 minuter</a:t>
+              <a:t>11.00–16.00: labbet, lunch 12.00–13.00</a:t>
             </a:r>
           </a:p>
         </p:txBody>
@@ -12432,7 +12432,7 @@
                 <a:ea typeface="Calibri"/>
                 <a:cs typeface="Calibri"/>
               </a:rPr>
-              <a:t>M motorn, S startaren och skylten, T tången: 25 minuter var</a:t>
+              <a:t>M motorn, S startaren och skylten, T tången: 40 minuter var</a:t>
             </a:r>
           </a:p>
           <a:p xmlns:a="http://schemas.openxmlformats.org/drawingml/2006/main">
@@ -12455,7 +12455,7 @@
                 <a:ea typeface="Calibri"/>
                 <a:cs typeface="Calibri"/>
               </a:rPr>
-              <a:t>Sist resultat på tavlan, protokoll och återkoppling</a:t>
+              <a:t>Felsökning i plinten, 15 minuter per grupp. Sist resultat och protokoll</a:t>
             </a:r>
           </a:p>
         </p:txBody>
@@ -12512,7 +12512,7 @@
                 <a:ea typeface="Calibri"/>
                 <a:cs typeface="Calibri"/>
               </a:rPr>
-              <a:t>Förbered övning 3.1–3.5 före träffen. Övning 3.6–3.10 görs efter labbet.</a:t>
+              <a:t>Övning 3.6–3.10 görs efter labbet.</a:t>
             </a:r>
           </a:p>
           <a:p xmlns:a="http://schemas.openxmlformats.org/drawingml/2006/main">

</xml_diff>

<commit_message>
Sjöskolan v41: fredagens genomgång av del 3 på distans, labbet på plats 11.00–16.00
Co-Authored-By: Claude Opus 5.5 <noreply@anthropic.com>
Claude-Session: https://claude.ai/code/session_011V9KjBb53XrDm23Dw58SH3
</commit_message>
<xml_diff>
--- a/sjoskolan/vecka-41/aktuell/v41_03_Fysisk_traff_och_matning_elev.pptx
+++ b/sjoskolan/vecka-41/aktuell/v41_03_Fysisk_traff_och_matning_elev.pptx
@@ -12238,7 +12238,7 @@
                 <a:ea typeface="Calibri"/>
                 <a:cs typeface="Calibri"/>
               </a:rPr>
-              <a:t>09.00–11.00: genomgång av del 3</a:t>
+              <a:t>09.00–11.00 på distans: läs genomgången själv</a:t>
             </a:r>
           </a:p>
         </p:txBody>
@@ -12318,7 +12318,7 @@
                 <a:ea typeface="Calibri"/>
                 <a:cs typeface="Calibri"/>
               </a:rPr>
-              <a:t>Övning 3.1–3.5 och gemensam förutsägelse: 2R i Y, (2/3) · R i Δ</a:t>
+              <a:t>Gör övning 3.1–3.5 och skriv dina förutsägelser i protokollet</a:t>
             </a:r>
           </a:p>
         </p:txBody>
@@ -12375,7 +12375,7 @@
                 <a:ea typeface="Calibri"/>
                 <a:cs typeface="Calibri"/>
               </a:rPr>
-              <a:t>11.00–16.00: labbet, lunch 12.00–13.00</a:t>
+              <a:t>11.00–16.00 på plats: labbet, lunch 12.00–13.00</a:t>
             </a:r>
           </a:p>
         </p:txBody>

</xml_diff>

<commit_message>
Sjöskolan v41: del 3 läses efter del 2 som avslutning på veckan, labbet fredag 11.00–16.00
Co-Authored-By: Claude Opus 5.5 <noreply@anthropic.com>
Claude-Session: https://claude.ai/code/session_011V9KjBb53XrDm23Dw58SH3
</commit_message>
<xml_diff>
--- a/sjoskolan/vecka-41/aktuell/v41_03_Fysisk_traff_och_matning_elev.pptx
+++ b/sjoskolan/vecka-41/aktuell/v41_03_Fysisk_traff_och_matning_elev.pptx
@@ -12238,7 +12238,7 @@
                 <a:ea typeface="Calibri"/>
                 <a:cs typeface="Calibri"/>
               </a:rPr>
-              <a:t>09.00–11.00 på distans: läs genomgången själv</a:t>
+              <a:t>Före fredag: läs genomgången själv efter del 2</a:t>
             </a:r>
           </a:p>
         </p:txBody>
@@ -12375,7 +12375,7 @@
                 <a:ea typeface="Calibri"/>
                 <a:cs typeface="Calibri"/>
               </a:rPr>
-              <a:t>11.00–16.00 på plats: labbet, lunch 12.00–13.00</a:t>
+              <a:t>Fredag 11.00–16.00 på plats: labbet, lunch 12.00–13.00</a:t>
             </a:r>
           </a:p>
         </p:txBody>

</xml_diff>

<commit_message>
Sjöskolan v41: 3D-figurer i del 3 och vid labbstationerna
Motorns delar, plinten, startaren och strömtången i presentationen för del 3,
renderade ur Motorlabbets bänk. Labbet.html visar station M, S och T, och
labbhandboken visar dessutom de tre felen i felsökningen.

Co-Authored-By: Claude Opus 5.5 <noreply@anthropic.com>
Claude-Session: https://claude.ai/code/session_011V9KjBb53XrDm23Dw58SH3
</commit_message>
<xml_diff>
--- a/sjoskolan/vecka-41/aktuell/v41_03_Fysisk_traff_och_matning_elev.pptx
+++ b/sjoskolan/vecka-41/aktuell/v41_03_Fysisk_traff_och_matning_elev.pptx
@@ -6827,14 +6827,14 @@
       </p:sp>
       <p:pic xmlns:a="http://schemas.openxmlformats.org/drawingml/2006/main" xmlns:r="http://schemas.openxmlformats.org/officeDocument/2006/relationships">
         <p:nvPicPr>
-          <p:cNvPr id="9" name="Figur: Trefasmotor från sidan utan etiketter; vilken del som" descr="Trefasmotor från sidan utan etiketter; vilken del som öppnas och vilka uppgifter som avgör kopplingen efterfrågas"/>
+          <p:cNvPr id="9" name="Figur: Labbets trefasmotor i 3D med stängd kopp" descr="Labbets trefasmotor i 3D med stängd kopplingslåda och märkskylten på stommen, utan etiketter"/>
           <p:cNvPicPr>
             <a:picLocks noChangeAspect="1"/>
           </p:cNvPicPr>
           <p:nvPr/>
         </p:nvPicPr>
         <p:blipFill>
-          <a:blip r:embed="rId3"/>
+          <a:blip r:embed="rId4"/>
           <a:stretch>
             <a:fillRect/>
           </a:stretch>
@@ -6842,7 +6842,7 @@
         <p:spPr>
           <a:xfrm>
             <a:off x="4846320" y="2331720"/>
-            <a:ext cx="3931920" cy="2561913"/>
+            <a:ext cx="3931920" cy="2444939"/>
           </a:xfrm>
           <a:prstGeom prst="rect">
             <a:avLst/>
@@ -8605,8 +8605,8 @@
         </p:nvSpPr>
         <p:spPr>
           <a:xfrm xmlns:a="http://schemas.openxmlformats.org/drawingml/2006/main">
-            <a:off x="762000" y="1619250"/>
-            <a:ext cx="7620000" cy="752475"/>
+            <a:off x="758952" y="1618488"/>
+            <a:ext cx="7616952" cy="987552"/>
           </a:xfrm>
           <a:prstGeom xmlns:a="http://schemas.openxmlformats.org/drawingml/2006/main" prst="rect">
             <a:avLst/>
@@ -8687,8 +8687,8 @@
         </p:nvSpPr>
         <p:spPr>
           <a:xfrm xmlns:a="http://schemas.openxmlformats.org/drawingml/2006/main">
-            <a:off x="762000" y="4791075"/>
-            <a:ext cx="7620000" cy="457200"/>
+            <a:off x="758952" y="4791456"/>
+            <a:ext cx="7616952" cy="457200"/>
           </a:xfrm>
           <a:prstGeom xmlns:a="http://schemas.openxmlformats.org/drawingml/2006/main" prst="rect">
             <a:avLst/>
@@ -8745,8 +8745,8 @@
         </p:nvSpPr>
         <p:spPr>
           <a:xfrm xmlns:a="http://schemas.openxmlformats.org/drawingml/2006/main">
-            <a:off x="762000" y="5343525"/>
-            <a:ext cx="7620000" cy="666750"/>
+            <a:off x="758952" y="5340096"/>
+            <a:ext cx="7616952" cy="667512"/>
           </a:xfrm>
           <a:prstGeom xmlns:a="http://schemas.openxmlformats.org/drawingml/2006/main" prst="rect">
             <a:avLst/>
@@ -8871,22 +8871,22 @@
       </p:sp>
       <p:pic xmlns:a="http://schemas.openxmlformats.org/drawingml/2006/main" xmlns:r="http://schemas.openxmlformats.org/officeDocument/2006/relationships">
         <p:nvPicPr>
-          <p:cNvPr id="38" name="Figur: Startarens delar: kontaktor K1 med spole A1–A2, huvud" descr="Startarens delar: kontaktor K1 med spole A1–A2, huvudkontakter 1–2, 3–4, 5–6, hjälpkontakt 13–14 (NO) och överlastrelä F2 med 95–96 (NC)"/>
+          <p:cNvPr id="38" name="Figur: Startaren med locket av i 3D: kontaktor " descr="Startaren med locket av i 3D: kontaktor K1 med spolen A1–A2, huvudkontakter 1–2, 3–4, 5–6, hjälpkontakt 13–14 (NO), överlastrelä F2 med 95–96 (NC), inställningsratt och testknapp"/>
           <p:cNvPicPr>
             <a:picLocks noChangeAspect="1"/>
           </p:cNvPicPr>
           <p:nvPr/>
         </p:nvPicPr>
         <p:blipFill>
-          <a:blip r:embed="rId4"/>
+          <a:blip r:embed="rId5"/>
           <a:stretch>
             <a:fillRect/>
           </a:stretch>
         </p:blipFill>
         <p:spPr>
           <a:xfrm>
-            <a:off x="2231136" y="2395728"/>
-            <a:ext cx="4681728" cy="2340864"/>
+            <a:off x="2612017" y="2651760"/>
+            <a:ext cx="3919964" cy="2084831"/>
           </a:xfrm>
           <a:prstGeom prst="rect">
             <a:avLst/>
@@ -9013,8 +9013,8 @@
         </p:nvSpPr>
         <p:spPr>
           <a:xfrm xmlns:a="http://schemas.openxmlformats.org/drawingml/2006/main">
-            <a:off x="762000" y="1619250"/>
-            <a:ext cx="3977639" cy="1466850"/>
+            <a:off x="758952" y="1618488"/>
+            <a:ext cx="7616952" cy="640080"/>
           </a:xfrm>
           <a:prstGeom xmlns:a="http://schemas.openxmlformats.org/drawingml/2006/main" prst="rect">
             <a:avLst/>
@@ -9095,8 +9095,8 @@
         </p:nvSpPr>
         <p:spPr>
           <a:xfrm xmlns:a="http://schemas.openxmlformats.org/drawingml/2006/main">
-            <a:off x="762000" y="3200400"/>
-            <a:ext cx="3977639" cy="838200"/>
+            <a:off x="758952" y="4242816"/>
+            <a:ext cx="7616952" cy="749808"/>
           </a:xfrm>
           <a:prstGeom xmlns:a="http://schemas.openxmlformats.org/drawingml/2006/main" prst="rect">
             <a:avLst/>
@@ -9177,8 +9177,8 @@
         </p:nvSpPr>
         <p:spPr>
           <a:xfrm xmlns:a="http://schemas.openxmlformats.org/drawingml/2006/main">
-            <a:off x="762000" y="4429125"/>
-            <a:ext cx="3977639" cy="1352550"/>
+            <a:off x="758952" y="5212080"/>
+            <a:ext cx="7616952" cy="566928"/>
           </a:xfrm>
           <a:prstGeom xmlns:a="http://schemas.openxmlformats.org/drawingml/2006/main" prst="rect">
             <a:avLst/>
@@ -9303,22 +9303,22 @@
       </p:sp>
       <p:pic xmlns:a="http://schemas.openxmlformats.org/drawingml/2006/main" xmlns:r="http://schemas.openxmlformats.org/officeDocument/2006/relationships">
         <p:nvPicPr>
-          <p:cNvPr id="9" name="Figur: Strömtångens käft: en ledare ger I, två " descr="Strömtångens käft: en ledare ger I, två varv ger 2 · I, hårnål med ström in och ut ger 0"/>
+          <p:cNvPr id="9" name="Figur: Strömtången runt labbsladden från aggreg" descr="Strömtången runt labbsladden från aggregatet på 2,00 A: en gång genom käften visar I, två varv visar 2 · I, hårnål ut och tillbaka visar 0"/>
           <p:cNvPicPr>
             <a:picLocks noChangeAspect="1"/>
           </p:cNvPicPr>
           <p:nvPr/>
         </p:nvPicPr>
         <p:blipFill>
-          <a:blip r:embed="rId3"/>
+          <a:blip r:embed="rId4"/>
           <a:stretch>
             <a:fillRect/>
           </a:stretch>
         </p:blipFill>
         <p:spPr>
           <a:xfrm>
-            <a:off x="4892040" y="1645920"/>
-            <a:ext cx="3886200" cy="2027729"/>
+            <a:off x="2103120" y="2304288"/>
+            <a:ext cx="4937760" cy="1920240"/>
           </a:xfrm>
           <a:prstGeom prst="rect">
             <a:avLst/>
@@ -16248,8 +16248,8 @@
         </p:nvSpPr>
         <p:spPr>
           <a:xfrm xmlns:a="http://schemas.openxmlformats.org/drawingml/2006/main">
-            <a:off x="762000" y="1619250"/>
-            <a:ext cx="3977639" cy="1466850"/>
+            <a:off x="758952" y="1618488"/>
+            <a:ext cx="7616952" cy="566928"/>
           </a:xfrm>
           <a:prstGeom xmlns:a="http://schemas.openxmlformats.org/drawingml/2006/main" prst="rect">
             <a:avLst/>
@@ -16330,8 +16330,8 @@
         </p:nvSpPr>
         <p:spPr>
           <a:xfrm xmlns:a="http://schemas.openxmlformats.org/drawingml/2006/main">
-            <a:off x="762000" y="3200400"/>
-            <a:ext cx="3977639" cy="838200"/>
+            <a:off x="758952" y="4425696"/>
+            <a:ext cx="7616952" cy="457200"/>
           </a:xfrm>
           <a:prstGeom xmlns:a="http://schemas.openxmlformats.org/drawingml/2006/main" prst="rect">
             <a:avLst/>
@@ -16388,8 +16388,8 @@
         </p:nvSpPr>
         <p:spPr>
           <a:xfrm xmlns:a="http://schemas.openxmlformats.org/drawingml/2006/main">
-            <a:off x="762000" y="4429125"/>
-            <a:ext cx="3977639" cy="1352550"/>
+            <a:off x="758952" y="4956048"/>
+            <a:ext cx="7616952" cy="658368"/>
           </a:xfrm>
           <a:prstGeom xmlns:a="http://schemas.openxmlformats.org/drawingml/2006/main" prst="rect">
             <a:avLst/>
@@ -16514,22 +16514,22 @@
       </p:sp>
       <p:pic xmlns:a="http://schemas.openxmlformats.org/drawingml/2006/main" xmlns:r="http://schemas.openxmlformats.org/officeDocument/2006/relationships">
         <p:nvPicPr>
-          <p:cNvPr id="9" name="Figur: Trefasmotor från sidan: kopplingslåda me" descr="Trefasmotor från sidan: kopplingslåda med plint, fläktkåpa med fläkt, stomme med kylflänsar, lagersköldar, axel med kil, märkskylt och fötter"/>
+          <p:cNvPr id="9" name="Figur: Labbets trefasmotor i 3D: fläktkåpa med " descr="Labbets trefasmotor i 3D: fläktkåpa med fläkten under, stomme med kylflänsar, fot, kopplingslåda med plinten, märkskylt, axel med kil och lagersköld"/>
           <p:cNvPicPr>
             <a:picLocks noChangeAspect="1"/>
           </p:cNvPicPr>
           <p:nvPr/>
         </p:nvPicPr>
         <p:blipFill>
-          <a:blip r:embed="rId3"/>
+          <a:blip r:embed="rId4"/>
           <a:stretch>
             <a:fillRect/>
           </a:stretch>
         </p:blipFill>
         <p:spPr>
           <a:xfrm>
-            <a:off x="4892040" y="1645920"/>
-            <a:ext cx="3886200" cy="2532123"/>
+            <a:off x="2204249" y="2240280"/>
+            <a:ext cx="4735501" cy="2103120"/>
           </a:xfrm>
           <a:prstGeom prst="rect">
             <a:avLst/>
@@ -16977,14 +16977,14 @@
       </p:sp>
       <p:pic xmlns:a="http://schemas.openxmlformats.org/drawingml/2006/main" xmlns:r="http://schemas.openxmlformats.org/officeDocument/2006/relationships">
         <p:nvPicPr>
-          <p:cNvPr id="9" name="Figur: Plint med sex lindningsändar utan bleck; lindningarna" descr="Plint med sex lindningsändar utan bleck; lindningarna U1–U2, V1–V2 och W1–W2 streckade; ohmmeter mellan U1 och U2"/>
+          <p:cNvPr id="9" name="Figur: Plinten i kopplingslådan uppifrån, utan " descr="Plinten i kopplingslådan uppifrån, utan bleck: ohmmeterns sladdar på U1 och U2; lindningarna U1–U2, V1–V2 och W1–W2 streckade inne i motorn"/>
           <p:cNvPicPr>
             <a:picLocks noChangeAspect="1"/>
           </p:cNvPicPr>
           <p:nvPr/>
         </p:nvPicPr>
         <p:blipFill>
-          <a:blip r:embed="rId3"/>
+          <a:blip r:embed="rId4"/>
           <a:stretch>
             <a:fillRect/>
           </a:stretch>
@@ -16992,7 +16992,7 @@
         <p:spPr>
           <a:xfrm>
             <a:off x="4892040" y="1645920"/>
-            <a:ext cx="3886200" cy="2709112"/>
+            <a:ext cx="3886200" cy="3665982"/>
           </a:xfrm>
           <a:prstGeom prst="rect">
             <a:avLst/>

</xml_diff>